<commit_message>
Pipeline PPT: add recording-processing slide for mobile_1 and mobile_2
Slide 1 shows each robot's chain (Ouster lidar/IMU packets -> decode ->
retime -> GLIM; ZED SVO2 replay; RealSense/VSLAM copied) and the per-pass
merge; slide 2 is the reference pipeline.

Co-Authored-By: Claude Opus 5.5 <noreply@anthropic.com>
Claude-Session: https://claude.ai/code/session_01VemgbrpoRNyLKBeEk6r3sF
</commit_message>
<xml_diff>
--- a/scoop_testbed_paper/figs/fig_refpipeline.pptx
+++ b/scoop_testbed_paper/figs/fig_refpipeline.pptx
@@ -6,9 +6,10 @@
   </p:sldMasterIdLst>
   <p:sldIdLst>
     <p:sldId id="256" r:id="rId2"/>
+    <p:sldId id="257" r:id="rId3"/>
   </p:sldIdLst>
   <p:notesMasterIdLst>
-    <p:notesMasterId r:id="rId3"/>
+    <p:notesMasterId r:id="rId4"/>
   </p:notesMasterIdLst>
   <p:sldSz cx="12192000" cy="6858000"/>
   <p:notesSz cx="6858000" cy="12192000"/>
@@ -502,7 +503,7 @@
           <a:p>
             <a:r>
               <a:rPr lang="en-US" dirty="0"/>
-              <a:t>Top: the mapping session, once per site. GLIM with its pose-time correction, plane bundle adjustment and TSDF fusion give the frozen reference map and trajectory; the boards are posed in it and the infrastructure cameras placed through them. Wall thickness, loop closure, pose time and control distances check it. Bottom: every sequence is registered into the frozen map per agent, validated on held-out boards, and exported in the site frame.</a:t>
+              <a:t>Each robot's recording is processed on its own, then the pass is merged. mobile_1: its raw bag holds the Ouster's lidar and IMU packets; they are decoded into points and IMU in sensor time, retimed onto the PC clock with a clock fit, and the ZED IMU is re-synced to the Ouster IMU (its driver stamps it late, 2.12 s on 20260924). GLIM gives the LiDAR trajectory. The ZED's SVO2 is replayed into image, depth and odometry bags on the capture clock. mobile_2: the same Ouster chain; GLIM runs with its own config and its poses are moved 46 ms on export. Its RealSense and Isaac VSLAM topics are already on the PC clock and are copied. The merge checks every robot's bags against record.yaml and adds the calibrations; a pass with one robot uses its own retimed bag.</a:t>
             </a:r>
             <a:endParaRPr lang="en-US" dirty="0"/>
           </a:p>
@@ -526,6 +527,94 @@
             <a:fld id="{F7021451-1387-4CA6-816F-3879F97B5CBC}" type="slidenum">
               <a:rPr lang="en-US"/>
               <a:t>1</a:t>
+            </a:fld>
+            <a:endParaRPr lang="en-US"/>
+          </a:p>
+        </p:txBody>
+      </p:sp>
+    </p:spTree>
+    <p:extLst>
+      <p:ext uri="{BB962C8B-B14F-4D97-AF65-F5344CB8AC3E}">
+        <p14:creationId xmlns:p14="http://schemas.microsoft.com/office/powerpoint/2010/main" val="1024086991"/>
+      </p:ext>
+    </p:extLst>
+  </p:cSld>
+  <p:clrMapOvr>
+    <a:masterClrMapping/>
+  </p:clrMapOvr>
+</p:notes>
+</file>
+
+<file path=ppt/notesSlides/notesSlide2.xml><?xml version="1.0" encoding="utf-8"?>
+<p:notes xmlns:a="http://schemas.openxmlformats.org/drawingml/2006/main" xmlns:r="http://schemas.openxmlformats.org/officeDocument/2006/relationships" xmlns:p="http://schemas.openxmlformats.org/presentationml/2006/main">
+  <p:cSld>
+    <p:spTree>
+      <p:nvGrpSpPr>
+        <p:cNvPr id="1" name=""/>
+        <p:cNvGrpSpPr/>
+        <p:nvPr/>
+      </p:nvGrpSpPr>
+      <p:grpSpPr>
+        <a:xfrm>
+          <a:off x="0" y="0"/>
+          <a:ext cx="0" cy="0"/>
+          <a:chOff x="0" y="0"/>
+          <a:chExt cx="0" cy="0"/>
+        </a:xfrm>
+      </p:grpSpPr>
+      <p:sp>
+        <p:nvSpPr>
+          <p:cNvPr id="2" name="Slide Image Placeholder 1"/>
+          <p:cNvSpPr>
+            <a:spLocks noGrp="1" noRot="1" noChangeAspect="1"/>
+          </p:cNvSpPr>
+          <p:nvPr>
+            <p:ph type="sldImg"/>
+          </p:nvPr>
+        </p:nvSpPr>
+        <p:spPr/>
+      </p:sp>
+      <p:sp>
+        <p:nvSpPr>
+          <p:cNvPr id="3" name="Notes Placeholder 2"/>
+          <p:cNvSpPr>
+            <a:spLocks noGrp="1"/>
+          </p:cNvSpPr>
+          <p:nvPr>
+            <p:ph type="body" idx="1"/>
+          </p:nvPr>
+        </p:nvSpPr>
+        <p:spPr/>
+        <p:txBody>
+          <a:bodyPr/>
+          <a:lstStyle/>
+          <a:p>
+            <a:r>
+              <a:rPr lang="en-US" dirty="0"/>
+              <a:t>Top: the mapping session, once per site. GLIM with its pose-time correction, plane bundle adjustment and TSDF fusion give the frozen reference map and trajectory; the boards are posed in it and the infrastructure cameras placed through them. Wall thickness, loop closure, pose time and control distances check it. Bottom: every sequence is registered into the frozen map per agent, validated on held-out boards, and exported in the site frame.</a:t>
+            </a:r>
+            <a:endParaRPr lang="en-US" dirty="0"/>
+          </a:p>
+        </p:txBody>
+      </p:sp>
+      <p:sp>
+        <p:nvSpPr>
+          <p:cNvPr id="4" name="Slide Number Placeholder 3"/>
+          <p:cNvSpPr>
+            <a:spLocks noGrp="1"/>
+          </p:cNvSpPr>
+          <p:nvPr>
+            <p:ph type="sldNum" sz="quarter" idx="10"/>
+          </p:nvPr>
+        </p:nvSpPr>
+        <p:spPr/>
+        <p:txBody>
+          <a:bodyPr/>
+          <a:lstStyle/>
+          <a:p>
+            <a:fld id="{F7021451-1387-4CA6-816F-3879F97B5CBC}" type="slidenum">
+              <a:rPr lang="en-US"/>
+              <a:t>2</a:t>
             </a:fld>
             <a:endParaRPr lang="en-US"/>
           </a:p>
@@ -883,7 +972,7 @@
         </p:nvSpPr>
         <p:spPr>
           <a:xfrm>
-            <a:off x="457200" y="411480"/>
+            <a:off x="457200" y="365760"/>
             <a:ext cx="11247120" cy="640080"/>
           </a:xfrm>
           <a:prstGeom prst="rect">
@@ -900,7 +989,7 @@
               <a:buNone/>
             </a:pPr>
             <a:r>
-              <a:rPr lang="en-US" sz="3600" b="1" dirty="0">
+              <a:rPr lang="en-US" sz="3200" b="1" dirty="0">
                 <a:solidFill>
                   <a:srgbClr val="14213D"/>
                 </a:solidFill>
@@ -908,9 +997,1976 @@
                 <a:ea typeface="Cambria" pitchFamily="34" charset="-122"/>
                 <a:cs typeface="Cambria" pitchFamily="34" charset="-120"/>
               </a:rPr>
+              <a:t>Recording processing, per robot and pass</a:t>
+            </a:r>
+            <a:endParaRPr lang="en-US" sz="3200" dirty="0"/>
+          </a:p>
+        </p:txBody>
+      </p:sp>
+      <p:sp>
+        <p:nvSpPr>
+          <p:cNvPr id="3" name="mobile_1 lane"/>
+          <p:cNvSpPr/>
+          <p:nvPr/>
+        </p:nvSpPr>
+        <p:spPr>
+          <a:xfrm>
+            <a:off x="524847" y="1393527"/>
+            <a:ext cx="8861798" cy="2412754"/>
+          </a:xfrm>
+          <a:prstGeom prst="roundRect">
+            <a:avLst>
+              <a:gd name="adj" fmla="val 3790"/>
+            </a:avLst>
+          </a:prstGeom>
+          <a:solidFill>
+            <a:srgbClr val="EEF1F5"/>
+          </a:solidFill>
+          <a:ln w="12700">
+            <a:solidFill>
+              <a:srgbClr val="A7B0C0"/>
+            </a:solidFill>
+            <a:prstDash val="solid"/>
+          </a:ln>
+        </p:spPr>
+      </p:sp>
+      <p:sp>
+        <p:nvSpPr>
+          <p:cNvPr id="4" name="mobile_1 lane title"/>
+          <p:cNvSpPr txBox="1"/>
+          <p:nvPr/>
+        </p:nvSpPr>
+        <p:spPr>
+          <a:xfrm>
+            <a:off x="660142" y="1457535"/>
+            <a:ext cx="8591209" cy="274320"/>
+          </a:xfrm>
+          <a:prstGeom prst="rect">
+            <a:avLst/>
+          </a:prstGeom>
+          <a:noFill/>
+          <a:ln/>
+        </p:spPr>
+        <p:txBody>
+          <a:bodyPr wrap="square" lIns="0" tIns="0" rIns="0" bIns="0" rtlCol="0" anchor="ctr"/>
+          <a:lstStyle/>
+          <a:p>
+            <a:pPr indent="0" marL="0">
+              <a:buNone/>
+            </a:pPr>
+            <a:r>
+              <a:rPr lang="en-US" sz="1300" b="1" dirty="0">
+                <a:solidFill>
+                  <a:srgbClr val="14213D"/>
+                </a:solidFill>
+                <a:latin typeface="Calibri" pitchFamily="34" charset="0"/>
+                <a:ea typeface="Calibri" pitchFamily="34" charset="-122"/>
+                <a:cs typeface="Calibri" pitchFamily="34" charset="-120"/>
+              </a:rPr>
+              <a:t>mobile_1  ·  Ouster LiDAR + ZED 2i</a:t>
+            </a:r>
+            <a:endParaRPr lang="en-US" sz="1300" dirty="0"/>
+          </a:p>
+        </p:txBody>
+      </p:sp>
+      <p:sp>
+        <p:nvSpPr>
+          <p:cNvPr id="5" name="m1 raw bag"/>
+          <p:cNvSpPr/>
+          <p:nvPr/>
+        </p:nvSpPr>
+        <p:spPr>
+          <a:xfrm>
+            <a:off x="660142" y="1979804"/>
+            <a:ext cx="1398044" cy="811768"/>
+          </a:xfrm>
+          <a:prstGeom prst="roundRect">
+            <a:avLst>
+              <a:gd name="adj" fmla="val 6759"/>
+            </a:avLst>
+          </a:prstGeom>
+          <a:solidFill>
+            <a:srgbClr val="FFFFFF"/>
+          </a:solidFill>
+          <a:ln w="15875">
+            <a:solidFill>
+              <a:srgbClr val="14213D"/>
+            </a:solidFill>
+          </a:ln>
+        </p:spPr>
+        <p:txBody>
+          <a:bodyPr wrap="square" lIns="25400" tIns="25400" rIns="25400" bIns="25400" rtlCol="0" anchor="ctr"/>
+          <a:lstStyle/>
+          <a:p>
+            <a:pPr algn="ctr" indent="0" marL="0">
+              <a:buNone/>
+            </a:pPr>
+            <a:r>
+              <a:rPr lang="en-US" sz="1100" dirty="0">
+                <a:solidFill>
+                  <a:srgbClr val="14213D"/>
+                </a:solidFill>
+                <a:latin typeface="Calibri" pitchFamily="34" charset="0"/>
+                <a:ea typeface="Calibri" pitchFamily="34" charset="-122"/>
+                <a:cs typeface="Calibri" pitchFamily="34" charset="-120"/>
+              </a:rPr>
+              <a:t>Raw bag</a:t>
+            </a:r>
+            <a:endParaRPr lang="en-US" sz="1100" dirty="0"/>
+          </a:p>
+          <a:p>
+            <a:pPr algn="ctr" indent="0" marL="0">
+              <a:buNone/>
+            </a:pPr>
+            <a:r>
+              <a:rPr lang="en-US" sz="1100" dirty="0">
+                <a:solidFill>
+                  <a:srgbClr val="14213D"/>
+                </a:solidFill>
+                <a:latin typeface="Calibri" pitchFamily="34" charset="0"/>
+                <a:ea typeface="Calibri" pitchFamily="34" charset="-122"/>
+                <a:cs typeface="Calibri" pitchFamily="34" charset="-120"/>
+              </a:rPr>
+              <a:t>lidar + IMU packets,</a:t>
+            </a:r>
+            <a:endParaRPr lang="en-US" sz="1100" dirty="0"/>
+          </a:p>
+          <a:p>
+            <a:pPr algn="ctr" indent="0" marL="0">
+              <a:buNone/>
+            </a:pPr>
+            <a:r>
+              <a:rPr lang="en-US" sz="1100" dirty="0">
+                <a:solidFill>
+                  <a:srgbClr val="14213D"/>
+                </a:solidFill>
+                <a:latin typeface="Calibri" pitchFamily="34" charset="0"/>
+                <a:ea typeface="Calibri" pitchFamily="34" charset="-122"/>
+                <a:cs typeface="Calibri" pitchFamily="34" charset="-120"/>
+              </a:rPr>
+              <a:t>metadata, ZED IMU</a:t>
+            </a:r>
+            <a:endParaRPr lang="en-US" sz="1100" dirty="0"/>
+          </a:p>
+        </p:txBody>
+      </p:sp>
+      <p:sp>
+        <p:nvSpPr>
+          <p:cNvPr id="6" name="m1 decode"/>
+          <p:cNvSpPr/>
+          <p:nvPr/>
+        </p:nvSpPr>
+        <p:spPr>
+          <a:xfrm>
+            <a:off x="2283677" y="1979804"/>
+            <a:ext cx="1578437" cy="811768"/>
+          </a:xfrm>
+          <a:prstGeom prst="roundRect">
+            <a:avLst>
+              <a:gd name="adj" fmla="val 6759"/>
+            </a:avLst>
+          </a:prstGeom>
+          <a:solidFill>
+            <a:srgbClr val="FFFFFF"/>
+          </a:solidFill>
+          <a:ln w="15875">
+            <a:solidFill>
+              <a:srgbClr val="14213D"/>
+            </a:solidFill>
+          </a:ln>
+        </p:spPr>
+        <p:txBody>
+          <a:bodyPr wrap="square" lIns="25400" tIns="25400" rIns="25400" bIns="25400" rtlCol="0" anchor="ctr"/>
+          <a:lstStyle/>
+          <a:p>
+            <a:pPr algn="ctr" indent="0" marL="0">
+              <a:buNone/>
+            </a:pPr>
+            <a:r>
+              <a:rPr lang="en-US" sz="1100" dirty="0">
+                <a:solidFill>
+                  <a:srgbClr val="14213D"/>
+                </a:solidFill>
+                <a:latin typeface="Calibri" pitchFamily="34" charset="0"/>
+                <a:ea typeface="Calibri" pitchFamily="34" charset="-122"/>
+                <a:cs typeface="Calibri" pitchFamily="34" charset="-120"/>
+              </a:rPr>
+              <a:t>Decode</a:t>
+            </a:r>
+            <a:endParaRPr lang="en-US" sz="1100" dirty="0"/>
+          </a:p>
+          <a:p>
+            <a:pPr algn="ctr" indent="0" marL="0">
+              <a:buNone/>
+            </a:pPr>
+            <a:r>
+              <a:rPr lang="en-US" sz="1100" dirty="0">
+                <a:solidFill>
+                  <a:srgbClr val="14213D"/>
+                </a:solidFill>
+                <a:latin typeface="Calibri" pitchFamily="34" charset="0"/>
+                <a:ea typeface="Calibri" pitchFamily="34" charset="-122"/>
+                <a:cs typeface="Calibri" pitchFamily="34" charset="-120"/>
+              </a:rPr>
+              <a:t>packets → points + IMU</a:t>
+            </a:r>
+            <a:endParaRPr lang="en-US" sz="1100" dirty="0"/>
+          </a:p>
+          <a:p>
+            <a:pPr algn="ctr" indent="0" marL="0">
+              <a:buNone/>
+            </a:pPr>
+            <a:r>
+              <a:rPr lang="en-US" sz="1100" dirty="0">
+                <a:solidFill>
+                  <a:srgbClr val="14213D"/>
+                </a:solidFill>
+                <a:latin typeface="Calibri" pitchFamily="34" charset="0"/>
+                <a:ea typeface="Calibri" pitchFamily="34" charset="-122"/>
+                <a:cs typeface="Calibri" pitchFamily="34" charset="-120"/>
+              </a:rPr>
+              <a:t>(sensor time, _mobile1)</a:t>
+            </a:r>
+            <a:endParaRPr lang="en-US" sz="1100" dirty="0"/>
+          </a:p>
+        </p:txBody>
+      </p:sp>
+      <p:sp>
+        <p:nvSpPr>
+          <p:cNvPr id="7" name="m1 retime"/>
+          <p:cNvSpPr/>
+          <p:nvPr/>
+        </p:nvSpPr>
+        <p:spPr>
+          <a:xfrm>
+            <a:off x="4087606" y="1979804"/>
+            <a:ext cx="1803928" cy="811768"/>
+          </a:xfrm>
+          <a:prstGeom prst="roundRect">
+            <a:avLst>
+              <a:gd name="adj" fmla="val 6759"/>
+            </a:avLst>
+          </a:prstGeom>
+          <a:solidFill>
+            <a:srgbClr val="FFFFFF"/>
+          </a:solidFill>
+          <a:ln w="15875">
+            <a:solidFill>
+              <a:srgbClr val="14213D"/>
+            </a:solidFill>
+          </a:ln>
+        </p:spPr>
+        <p:txBody>
+          <a:bodyPr wrap="square" lIns="25400" tIns="25400" rIns="25400" bIns="25400" rtlCol="0" anchor="ctr"/>
+          <a:lstStyle/>
+          <a:p>
+            <a:pPr algn="ctr" indent="0" marL="0">
+              <a:buNone/>
+            </a:pPr>
+            <a:r>
+              <a:rPr lang="en-US" sz="1100" dirty="0">
+                <a:solidFill>
+                  <a:srgbClr val="14213D"/>
+                </a:solidFill>
+                <a:latin typeface="Calibri" pitchFamily="34" charset="0"/>
+                <a:ea typeface="Calibri" pitchFamily="34" charset="-122"/>
+                <a:cs typeface="Calibri" pitchFamily="34" charset="-120"/>
+              </a:rPr>
+              <a:t>Retime</a:t>
+            </a:r>
+            <a:endParaRPr lang="en-US" sz="1100" dirty="0"/>
+          </a:p>
+          <a:p>
+            <a:pPr algn="ctr" indent="0" marL="0">
+              <a:buNone/>
+            </a:pPr>
+            <a:r>
+              <a:rPr lang="en-US" sz="1100" dirty="0">
+                <a:solidFill>
+                  <a:srgbClr val="14213D"/>
+                </a:solidFill>
+                <a:latin typeface="Calibri" pitchFamily="34" charset="0"/>
+                <a:ea typeface="Calibri" pitchFamily="34" charset="-122"/>
+                <a:cs typeface="Calibri" pitchFamily="34" charset="-120"/>
+              </a:rPr>
+              <a:t>sensor → PC clock (clock fit);</a:t>
+            </a:r>
+            <a:endParaRPr lang="en-US" sz="1100" dirty="0"/>
+          </a:p>
+          <a:p>
+            <a:pPr algn="ctr" indent="0" marL="0">
+              <a:buNone/>
+            </a:pPr>
+            <a:r>
+              <a:rPr lang="en-US" sz="1100" dirty="0">
+                <a:solidFill>
+                  <a:srgbClr val="14213D"/>
+                </a:solidFill>
+                <a:latin typeface="Calibri" pitchFamily="34" charset="0"/>
+                <a:ea typeface="Calibri" pitchFamily="34" charset="-122"/>
+                <a:cs typeface="Calibri" pitchFamily="34" charset="-120"/>
+              </a:rPr>
+              <a:t>ZED IMU re-synced to Ouster</a:t>
+            </a:r>
+            <a:endParaRPr lang="en-US" sz="1100" dirty="0"/>
+          </a:p>
+        </p:txBody>
+      </p:sp>
+      <p:sp>
+        <p:nvSpPr>
+          <p:cNvPr id="8" name="m1 GLIM"/>
+          <p:cNvSpPr/>
+          <p:nvPr/>
+        </p:nvSpPr>
+        <p:spPr>
+          <a:xfrm>
+            <a:off x="6117025" y="1979804"/>
+            <a:ext cx="1465692" cy="811768"/>
+          </a:xfrm>
+          <a:prstGeom prst="roundRect">
+            <a:avLst>
+              <a:gd name="adj" fmla="val 6759"/>
+            </a:avLst>
+          </a:prstGeom>
+          <a:solidFill>
+            <a:srgbClr val="FFFFFF"/>
+          </a:solidFill>
+          <a:ln w="15875">
+            <a:solidFill>
+              <a:srgbClr val="14213D"/>
+            </a:solidFill>
+          </a:ln>
+        </p:spPr>
+        <p:txBody>
+          <a:bodyPr wrap="square" lIns="25400" tIns="25400" rIns="25400" bIns="25400" rtlCol="0" anchor="ctr"/>
+          <a:lstStyle/>
+          <a:p>
+            <a:pPr algn="ctr" indent="0" marL="0">
+              <a:buNone/>
+            </a:pPr>
+            <a:r>
+              <a:rPr lang="en-US" sz="1100" dirty="0">
+                <a:solidFill>
+                  <a:srgbClr val="14213D"/>
+                </a:solidFill>
+                <a:latin typeface="Calibri" pitchFamily="34" charset="0"/>
+                <a:ea typeface="Calibri" pitchFamily="34" charset="-122"/>
+                <a:cs typeface="Calibri" pitchFamily="34" charset="-120"/>
+              </a:rPr>
+              <a:t>GLIM</a:t>
+            </a:r>
+            <a:endParaRPr lang="en-US" sz="1100" dirty="0"/>
+          </a:p>
+          <a:p>
+            <a:pPr algn="ctr" indent="0" marL="0">
+              <a:buNone/>
+            </a:pPr>
+            <a:r>
+              <a:rPr lang="en-US" sz="1100" dirty="0">
+                <a:solidFill>
+                  <a:srgbClr val="14213D"/>
+                </a:solidFill>
+                <a:latin typeface="Calibri" pitchFamily="34" charset="0"/>
+                <a:ea typeface="Calibri" pitchFamily="34" charset="-122"/>
+                <a:cs typeface="Calibri" pitchFamily="34" charset="-120"/>
+              </a:rPr>
+              <a:t>LiDAR-inertial</a:t>
+            </a:r>
+            <a:endParaRPr lang="en-US" sz="1100" dirty="0"/>
+          </a:p>
+          <a:p>
+            <a:pPr algn="ctr" indent="0" marL="0">
+              <a:buNone/>
+            </a:pPr>
+            <a:r>
+              <a:rPr lang="en-US" sz="1100" dirty="0">
+                <a:solidFill>
+                  <a:srgbClr val="14213D"/>
+                </a:solidFill>
+                <a:latin typeface="Calibri" pitchFamily="34" charset="0"/>
+                <a:ea typeface="Calibri" pitchFamily="34" charset="-122"/>
+                <a:cs typeface="Calibri" pitchFamily="34" charset="-120"/>
+              </a:rPr>
+              <a:t>SLAM</a:t>
+            </a:r>
+            <a:endParaRPr lang="en-US" sz="1100" dirty="0"/>
+          </a:p>
+        </p:txBody>
+      </p:sp>
+      <p:sp>
+        <p:nvSpPr>
+          <p:cNvPr id="9" name="m1 trajectory"/>
+          <p:cNvSpPr/>
+          <p:nvPr/>
+        </p:nvSpPr>
+        <p:spPr>
+          <a:xfrm>
+            <a:off x="7808208" y="1979804"/>
+            <a:ext cx="1352946" cy="811768"/>
+          </a:xfrm>
+          <a:prstGeom prst="parallelogram">
+            <a:avLst/>
+          </a:prstGeom>
+          <a:solidFill>
+            <a:srgbClr val="FBE6D0"/>
+          </a:solidFill>
+          <a:ln w="19050">
+            <a:solidFill>
+              <a:srgbClr val="D9822B"/>
+            </a:solidFill>
+          </a:ln>
+        </p:spPr>
+        <p:txBody>
+          <a:bodyPr wrap="square" lIns="25400" tIns="25400" rIns="25400" bIns="25400" rtlCol="0" anchor="ctr"/>
+          <a:lstStyle/>
+          <a:p>
+            <a:pPr algn="ctr" indent="0" marL="0">
+              <a:buNone/>
+            </a:pPr>
+            <a:r>
+              <a:rPr lang="en-US" sz="1100" b="1" dirty="0">
+                <a:solidFill>
+                  <a:srgbClr val="14213D"/>
+                </a:solidFill>
+                <a:latin typeface="Calibri" pitchFamily="34" charset="0"/>
+                <a:ea typeface="Calibri" pitchFamily="34" charset="-122"/>
+                <a:cs typeface="Calibri" pitchFamily="34" charset="-120"/>
+              </a:rPr>
+              <a:t>LiDAR</a:t>
+            </a:r>
+            <a:endParaRPr lang="en-US" sz="1100" dirty="0"/>
+          </a:p>
+          <a:p>
+            <a:pPr algn="ctr" indent="0" marL="0">
+              <a:buNone/>
+            </a:pPr>
+            <a:r>
+              <a:rPr lang="en-US" sz="1100" b="1" dirty="0">
+                <a:solidFill>
+                  <a:srgbClr val="14213D"/>
+                </a:solidFill>
+                <a:latin typeface="Calibri" pitchFamily="34" charset="0"/>
+                <a:ea typeface="Calibri" pitchFamily="34" charset="-122"/>
+                <a:cs typeface="Calibri" pitchFamily="34" charset="-120"/>
+              </a:rPr>
+              <a:t>trajectory</a:t>
+            </a:r>
+            <a:endParaRPr lang="en-US" sz="1100" dirty="0"/>
+          </a:p>
+        </p:txBody>
+      </p:sp>
+      <p:sp>
+        <p:nvSpPr>
+          <p:cNvPr id="10" name="Arrow"/>
+          <p:cNvSpPr/>
+          <p:nvPr/>
+        </p:nvSpPr>
+        <p:spPr>
+          <a:xfrm>
+            <a:off x="2058186" y="2385688"/>
+            <a:ext cx="225491" cy="0"/>
+          </a:xfrm>
+          <a:prstGeom prst="line">
+            <a:avLst/>
+          </a:prstGeom>
+          <a:noFill/>
+          <a:ln w="15875">
+            <a:solidFill>
+              <a:srgbClr val="14213D"/>
+            </a:solidFill>
+            <a:prstDash val="solid"/>
+            <a:tailEnd type="triangle"/>
+          </a:ln>
+        </p:spPr>
+      </p:sp>
+      <p:sp>
+        <p:nvSpPr>
+          <p:cNvPr id="11" name="Arrow"/>
+          <p:cNvSpPr/>
+          <p:nvPr/>
+        </p:nvSpPr>
+        <p:spPr>
+          <a:xfrm>
+            <a:off x="3862115" y="2385688"/>
+            <a:ext cx="225491" cy="0"/>
+          </a:xfrm>
+          <a:prstGeom prst="line">
+            <a:avLst/>
+          </a:prstGeom>
+          <a:noFill/>
+          <a:ln w="15875">
+            <a:solidFill>
+              <a:srgbClr val="14213D"/>
+            </a:solidFill>
+            <a:prstDash val="solid"/>
+            <a:tailEnd type="triangle"/>
+          </a:ln>
+        </p:spPr>
+      </p:sp>
+      <p:sp>
+        <p:nvSpPr>
+          <p:cNvPr id="12" name="Arrow"/>
+          <p:cNvSpPr/>
+          <p:nvPr/>
+        </p:nvSpPr>
+        <p:spPr>
+          <a:xfrm>
+            <a:off x="5891534" y="2385688"/>
+            <a:ext cx="225491" cy="0"/>
+          </a:xfrm>
+          <a:prstGeom prst="line">
+            <a:avLst/>
+          </a:prstGeom>
+          <a:noFill/>
+          <a:ln w="15875">
+            <a:solidFill>
+              <a:srgbClr val="14213D"/>
+            </a:solidFill>
+            <a:prstDash val="solid"/>
+            <a:tailEnd type="triangle"/>
+          </a:ln>
+        </p:spPr>
+      </p:sp>
+      <p:sp>
+        <p:nvSpPr>
+          <p:cNvPr id="13" name="Arrow"/>
+          <p:cNvSpPr/>
+          <p:nvPr/>
+        </p:nvSpPr>
+        <p:spPr>
+          <a:xfrm>
+            <a:off x="7582717" y="2385688"/>
+            <a:ext cx="225491" cy="0"/>
+          </a:xfrm>
+          <a:prstGeom prst="line">
+            <a:avLst/>
+          </a:prstGeom>
+          <a:noFill/>
+          <a:ln w="15875">
+            <a:solidFill>
+              <a:srgbClr val="14213D"/>
+            </a:solidFill>
+            <a:prstDash val="solid"/>
+            <a:tailEnd type="triangle"/>
+          </a:ln>
+        </p:spPr>
+      </p:sp>
+      <p:sp>
+        <p:nvSpPr>
+          <p:cNvPr id="14" name="m1 svo"/>
+          <p:cNvSpPr/>
+          <p:nvPr/>
+        </p:nvSpPr>
+        <p:spPr>
+          <a:xfrm>
+            <a:off x="660142" y="3017063"/>
+            <a:ext cx="1398044" cy="676473"/>
+          </a:xfrm>
+          <a:prstGeom prst="roundRect">
+            <a:avLst>
+              <a:gd name="adj" fmla="val 8110"/>
+            </a:avLst>
+          </a:prstGeom>
+          <a:solidFill>
+            <a:srgbClr val="FFFFFF"/>
+          </a:solidFill>
+          <a:ln w="15875">
+            <a:solidFill>
+              <a:srgbClr val="14213D"/>
+            </a:solidFill>
+          </a:ln>
+        </p:spPr>
+        <p:txBody>
+          <a:bodyPr wrap="square" lIns="25400" tIns="25400" rIns="25400" bIns="25400" rtlCol="0" anchor="ctr"/>
+          <a:lstStyle/>
+          <a:p>
+            <a:pPr algn="ctr" indent="0" marL="0">
+              <a:buNone/>
+            </a:pPr>
+            <a:r>
+              <a:rPr lang="en-US" sz="1100" dirty="0">
+                <a:solidFill>
+                  <a:srgbClr val="14213D"/>
+                </a:solidFill>
+                <a:latin typeface="Calibri" pitchFamily="34" charset="0"/>
+                <a:ea typeface="Calibri" pitchFamily="34" charset="-122"/>
+                <a:cs typeface="Calibri" pitchFamily="34" charset="-120"/>
+              </a:rPr>
+              <a:t>ZED SVO2</a:t>
+            </a:r>
+            <a:endParaRPr lang="en-US" sz="1100" dirty="0"/>
+          </a:p>
+          <a:p>
+            <a:pPr algn="ctr" indent="0" marL="0">
+              <a:buNone/>
+            </a:pPr>
+            <a:r>
+              <a:rPr lang="en-US" sz="1100" dirty="0">
+                <a:solidFill>
+                  <a:srgbClr val="14213D"/>
+                </a:solidFill>
+                <a:latin typeface="Calibri" pitchFamily="34" charset="0"/>
+                <a:ea typeface="Calibri" pitchFamily="34" charset="-122"/>
+                <a:cs typeface="Calibri" pitchFamily="34" charset="-120"/>
+              </a:rPr>
+              <a:t>(stereo video)</a:t>
+            </a:r>
+            <a:endParaRPr lang="en-US" sz="1100" dirty="0"/>
+          </a:p>
+        </p:txBody>
+      </p:sp>
+      <p:sp>
+        <p:nvSpPr>
+          <p:cNvPr id="15" name="m1 zed replay"/>
+          <p:cNvSpPr/>
+          <p:nvPr/>
+        </p:nvSpPr>
+        <p:spPr>
+          <a:xfrm>
+            <a:off x="2283677" y="3017063"/>
+            <a:ext cx="3607857" cy="676473"/>
+          </a:xfrm>
+          <a:prstGeom prst="roundRect">
+            <a:avLst>
+              <a:gd name="adj" fmla="val 8110"/>
+            </a:avLst>
+          </a:prstGeom>
+          <a:solidFill>
+            <a:srgbClr val="FFFFFF"/>
+          </a:solidFill>
+          <a:ln w="15875">
+            <a:solidFill>
+              <a:srgbClr val="14213D"/>
+            </a:solidFill>
+          </a:ln>
+        </p:spPr>
+        <p:txBody>
+          <a:bodyPr wrap="square" lIns="25400" tIns="25400" rIns="25400" bIns="25400" rtlCol="0" anchor="ctr"/>
+          <a:lstStyle/>
+          <a:p>
+            <a:pPr algn="ctr" indent="0" marL="0">
+              <a:buNone/>
+            </a:pPr>
+            <a:r>
+              <a:rPr lang="en-US" sz="1100" dirty="0">
+                <a:solidFill>
+                  <a:srgbClr val="14213D"/>
+                </a:solidFill>
+                <a:latin typeface="Calibri" pitchFamily="34" charset="0"/>
+                <a:ea typeface="Calibri" pitchFamily="34" charset="-122"/>
+                <a:cs typeface="Calibri" pitchFamily="34" charset="-120"/>
+              </a:rPr>
+              <a:t>ZED replay: images, depth, odometry, pose</a:t>
+            </a:r>
+            <a:endParaRPr lang="en-US" sz="1100" dirty="0"/>
+          </a:p>
+          <a:p>
+            <a:pPr algn="ctr" indent="0" marL="0">
+              <a:buNone/>
+            </a:pPr>
+            <a:r>
+              <a:rPr lang="en-US" sz="1100" dirty="0">
+                <a:solidFill>
+                  <a:srgbClr val="14213D"/>
+                </a:solidFill>
+                <a:latin typeface="Calibri" pitchFamily="34" charset="0"/>
+                <a:ea typeface="Calibri" pitchFamily="34" charset="-122"/>
+                <a:cs typeface="Calibri" pitchFamily="34" charset="-120"/>
+              </a:rPr>
+              <a:t>on the capture clock</a:t>
+            </a:r>
+            <a:endParaRPr lang="en-US" sz="1100" dirty="0"/>
+          </a:p>
+        </p:txBody>
+      </p:sp>
+      <p:sp>
+        <p:nvSpPr>
+          <p:cNvPr id="16" name="m1 zed bags"/>
+          <p:cNvSpPr/>
+          <p:nvPr/>
+        </p:nvSpPr>
+        <p:spPr>
+          <a:xfrm>
+            <a:off x="6117025" y="3017063"/>
+            <a:ext cx="1465692" cy="676473"/>
+          </a:xfrm>
+          <a:prstGeom prst="parallelogram">
+            <a:avLst/>
+          </a:prstGeom>
+          <a:solidFill>
+            <a:srgbClr val="FBE6D0"/>
+          </a:solidFill>
+          <a:ln w="19050">
+            <a:solidFill>
+              <a:srgbClr val="D9822B"/>
+            </a:solidFill>
+          </a:ln>
+        </p:spPr>
+        <p:txBody>
+          <a:bodyPr wrap="square" lIns="25400" tIns="25400" rIns="25400" bIns="25400" rtlCol="0" anchor="ctr"/>
+          <a:lstStyle/>
+          <a:p>
+            <a:pPr algn="ctr" indent="0" marL="0">
+              <a:buNone/>
+            </a:pPr>
+            <a:r>
+              <a:rPr lang="en-US" sz="1100" dirty="0">
+                <a:solidFill>
+                  <a:srgbClr val="14213D"/>
+                </a:solidFill>
+                <a:latin typeface="Calibri" pitchFamily="34" charset="0"/>
+                <a:ea typeface="Calibri" pitchFamily="34" charset="-122"/>
+                <a:cs typeface="Calibri" pitchFamily="34" charset="-120"/>
+              </a:rPr>
+              <a:t>ZED bags</a:t>
+            </a:r>
+            <a:endParaRPr lang="en-US" sz="1100" dirty="0"/>
+          </a:p>
+        </p:txBody>
+      </p:sp>
+      <p:sp>
+        <p:nvSpPr>
+          <p:cNvPr id="17" name="Arrow"/>
+          <p:cNvSpPr/>
+          <p:nvPr/>
+        </p:nvSpPr>
+        <p:spPr>
+          <a:xfrm>
+            <a:off x="2058186" y="3355299"/>
+            <a:ext cx="225491" cy="0"/>
+          </a:xfrm>
+          <a:prstGeom prst="line">
+            <a:avLst/>
+          </a:prstGeom>
+          <a:noFill/>
+          <a:ln w="15875">
+            <a:solidFill>
+              <a:srgbClr val="14213D"/>
+            </a:solidFill>
+            <a:prstDash val="solid"/>
+            <a:tailEnd type="triangle"/>
+          </a:ln>
+        </p:spPr>
+      </p:sp>
+      <p:sp>
+        <p:nvSpPr>
+          <p:cNvPr id="18" name="Arrow"/>
+          <p:cNvSpPr/>
+          <p:nvPr/>
+        </p:nvSpPr>
+        <p:spPr>
+          <a:xfrm>
+            <a:off x="5891534" y="3355299"/>
+            <a:ext cx="225491" cy="0"/>
+          </a:xfrm>
+          <a:prstGeom prst="line">
+            <a:avLst/>
+          </a:prstGeom>
+          <a:noFill/>
+          <a:ln w="15875">
+            <a:solidFill>
+              <a:srgbClr val="14213D"/>
+            </a:solidFill>
+            <a:prstDash val="solid"/>
+            <a:tailEnd type="triangle"/>
+          </a:ln>
+        </p:spPr>
+      </p:sp>
+      <p:sp>
+        <p:nvSpPr>
+          <p:cNvPr id="19" name="mobile_2 lane"/>
+          <p:cNvSpPr/>
+          <p:nvPr/>
+        </p:nvSpPr>
+        <p:spPr>
+          <a:xfrm>
+            <a:off x="524847" y="4031772"/>
+            <a:ext cx="8861798" cy="2412754"/>
+          </a:xfrm>
+          <a:prstGeom prst="roundRect">
+            <a:avLst>
+              <a:gd name="adj" fmla="val 3790"/>
+            </a:avLst>
+          </a:prstGeom>
+          <a:solidFill>
+            <a:srgbClr val="EEF1F5"/>
+          </a:solidFill>
+          <a:ln w="12700">
+            <a:solidFill>
+              <a:srgbClr val="A7B0C0"/>
+            </a:solidFill>
+            <a:prstDash val="solid"/>
+          </a:ln>
+        </p:spPr>
+      </p:sp>
+      <p:sp>
+        <p:nvSpPr>
+          <p:cNvPr id="20" name="mobile_2 lane title"/>
+          <p:cNvSpPr txBox="1"/>
+          <p:nvPr/>
+        </p:nvSpPr>
+        <p:spPr>
+          <a:xfrm>
+            <a:off x="660142" y="4095780"/>
+            <a:ext cx="8591209" cy="274320"/>
+          </a:xfrm>
+          <a:prstGeom prst="rect">
+            <a:avLst/>
+          </a:prstGeom>
+          <a:noFill/>
+          <a:ln/>
+        </p:spPr>
+        <p:txBody>
+          <a:bodyPr wrap="square" lIns="0" tIns="0" rIns="0" bIns="0" rtlCol="0" anchor="ctr"/>
+          <a:lstStyle/>
+          <a:p>
+            <a:pPr indent="0" marL="0">
+              <a:buNone/>
+            </a:pPr>
+            <a:r>
+              <a:rPr lang="en-US" sz="1300" b="1" dirty="0">
+                <a:solidFill>
+                  <a:srgbClr val="14213D"/>
+                </a:solidFill>
+                <a:latin typeface="Calibri" pitchFamily="34" charset="0"/>
+                <a:ea typeface="Calibri" pitchFamily="34" charset="-122"/>
+                <a:cs typeface="Calibri" pitchFamily="34" charset="-120"/>
+              </a:rPr>
+              <a:t>mobile_2  ·  Ouster LiDAR + RealSense + Isaac VSLAM</a:t>
+            </a:r>
+            <a:endParaRPr lang="en-US" sz="1300" dirty="0"/>
+          </a:p>
+        </p:txBody>
+      </p:sp>
+      <p:sp>
+        <p:nvSpPr>
+          <p:cNvPr id="21" name="m2 raw bag"/>
+          <p:cNvSpPr/>
+          <p:nvPr/>
+        </p:nvSpPr>
+        <p:spPr>
+          <a:xfrm>
+            <a:off x="660142" y="4595500"/>
+            <a:ext cx="1398044" cy="811768"/>
+          </a:xfrm>
+          <a:prstGeom prst="roundRect">
+            <a:avLst>
+              <a:gd name="adj" fmla="val 6759"/>
+            </a:avLst>
+          </a:prstGeom>
+          <a:solidFill>
+            <a:srgbClr val="FFFFFF"/>
+          </a:solidFill>
+          <a:ln w="15875">
+            <a:solidFill>
+              <a:srgbClr val="14213D"/>
+            </a:solidFill>
+          </a:ln>
+        </p:spPr>
+        <p:txBody>
+          <a:bodyPr wrap="square" lIns="25400" tIns="25400" rIns="25400" bIns="25400" rtlCol="0" anchor="ctr"/>
+          <a:lstStyle/>
+          <a:p>
+            <a:pPr algn="ctr" indent="0" marL="0">
+              <a:buNone/>
+            </a:pPr>
+            <a:r>
+              <a:rPr lang="en-US" sz="1100" dirty="0">
+                <a:solidFill>
+                  <a:srgbClr val="14213D"/>
+                </a:solidFill>
+                <a:latin typeface="Calibri" pitchFamily="34" charset="0"/>
+                <a:ea typeface="Calibri" pitchFamily="34" charset="-122"/>
+                <a:cs typeface="Calibri" pitchFamily="34" charset="-120"/>
+              </a:rPr>
+              <a:t>Raw bag</a:t>
+            </a:r>
+            <a:endParaRPr lang="en-US" sz="1100" dirty="0"/>
+          </a:p>
+          <a:p>
+            <a:pPr algn="ctr" indent="0" marL="0">
+              <a:buNone/>
+            </a:pPr>
+            <a:r>
+              <a:rPr lang="en-US" sz="1100" dirty="0">
+                <a:solidFill>
+                  <a:srgbClr val="14213D"/>
+                </a:solidFill>
+                <a:latin typeface="Calibri" pitchFamily="34" charset="0"/>
+                <a:ea typeface="Calibri" pitchFamily="34" charset="-122"/>
+                <a:cs typeface="Calibri" pitchFamily="34" charset="-120"/>
+              </a:rPr>
+              <a:t>lidar + IMU packets,</a:t>
+            </a:r>
+            <a:endParaRPr lang="en-US" sz="1100" dirty="0"/>
+          </a:p>
+          <a:p>
+            <a:pPr algn="ctr" indent="0" marL="0">
+              <a:buNone/>
+            </a:pPr>
+            <a:r>
+              <a:rPr lang="en-US" sz="1100" dirty="0">
+                <a:solidFill>
+                  <a:srgbClr val="14213D"/>
+                </a:solidFill>
+                <a:latin typeface="Calibri" pitchFamily="34" charset="0"/>
+                <a:ea typeface="Calibri" pitchFamily="34" charset="-122"/>
+                <a:cs typeface="Calibri" pitchFamily="34" charset="-120"/>
+              </a:rPr>
+              <a:t>metadata</a:t>
+            </a:r>
+            <a:endParaRPr lang="en-US" sz="1100" dirty="0"/>
+          </a:p>
+        </p:txBody>
+      </p:sp>
+      <p:sp>
+        <p:nvSpPr>
+          <p:cNvPr id="22" name="m2 decode"/>
+          <p:cNvSpPr/>
+          <p:nvPr/>
+        </p:nvSpPr>
+        <p:spPr>
+          <a:xfrm>
+            <a:off x="2283677" y="4595500"/>
+            <a:ext cx="1578437" cy="811768"/>
+          </a:xfrm>
+          <a:prstGeom prst="roundRect">
+            <a:avLst>
+              <a:gd name="adj" fmla="val 6759"/>
+            </a:avLst>
+          </a:prstGeom>
+          <a:solidFill>
+            <a:srgbClr val="FFFFFF"/>
+          </a:solidFill>
+          <a:ln w="15875">
+            <a:solidFill>
+              <a:srgbClr val="14213D"/>
+            </a:solidFill>
+          </a:ln>
+        </p:spPr>
+        <p:txBody>
+          <a:bodyPr wrap="square" lIns="25400" tIns="25400" rIns="25400" bIns="25400" rtlCol="0" anchor="ctr"/>
+          <a:lstStyle/>
+          <a:p>
+            <a:pPr algn="ctr" indent="0" marL="0">
+              <a:buNone/>
+            </a:pPr>
+            <a:r>
+              <a:rPr lang="en-US" sz="1100" dirty="0">
+                <a:solidFill>
+                  <a:srgbClr val="14213D"/>
+                </a:solidFill>
+                <a:latin typeface="Calibri" pitchFamily="34" charset="0"/>
+                <a:ea typeface="Calibri" pitchFamily="34" charset="-122"/>
+                <a:cs typeface="Calibri" pitchFamily="34" charset="-120"/>
+              </a:rPr>
+              <a:t>Decode</a:t>
+            </a:r>
+            <a:endParaRPr lang="en-US" sz="1100" dirty="0"/>
+          </a:p>
+          <a:p>
+            <a:pPr algn="ctr" indent="0" marL="0">
+              <a:buNone/>
+            </a:pPr>
+            <a:r>
+              <a:rPr lang="en-US" sz="1100" dirty="0">
+                <a:solidFill>
+                  <a:srgbClr val="14213D"/>
+                </a:solidFill>
+                <a:latin typeface="Calibri" pitchFamily="34" charset="0"/>
+                <a:ea typeface="Calibri" pitchFamily="34" charset="-122"/>
+                <a:cs typeface="Calibri" pitchFamily="34" charset="-120"/>
+              </a:rPr>
+              <a:t>packets → points + IMU</a:t>
+            </a:r>
+            <a:endParaRPr lang="en-US" sz="1100" dirty="0"/>
+          </a:p>
+          <a:p>
+            <a:pPr algn="ctr" indent="0" marL="0">
+              <a:buNone/>
+            </a:pPr>
+            <a:r>
+              <a:rPr lang="en-US" sz="1100" dirty="0">
+                <a:solidFill>
+                  <a:srgbClr val="14213D"/>
+                </a:solidFill>
+                <a:latin typeface="Calibri" pitchFamily="34" charset="0"/>
+                <a:ea typeface="Calibri" pitchFamily="34" charset="-122"/>
+                <a:cs typeface="Calibri" pitchFamily="34" charset="-120"/>
+              </a:rPr>
+              <a:t>(sensor time, _mobile2)</a:t>
+            </a:r>
+            <a:endParaRPr lang="en-US" sz="1100" dirty="0"/>
+          </a:p>
+        </p:txBody>
+      </p:sp>
+      <p:sp>
+        <p:nvSpPr>
+          <p:cNvPr id="23" name="m2 retime"/>
+          <p:cNvSpPr/>
+          <p:nvPr/>
+        </p:nvSpPr>
+        <p:spPr>
+          <a:xfrm>
+            <a:off x="4087606" y="4595500"/>
+            <a:ext cx="1803928" cy="811768"/>
+          </a:xfrm>
+          <a:prstGeom prst="roundRect">
+            <a:avLst>
+              <a:gd name="adj" fmla="val 6759"/>
+            </a:avLst>
+          </a:prstGeom>
+          <a:solidFill>
+            <a:srgbClr val="FFFFFF"/>
+          </a:solidFill>
+          <a:ln w="15875">
+            <a:solidFill>
+              <a:srgbClr val="14213D"/>
+            </a:solidFill>
+          </a:ln>
+        </p:spPr>
+        <p:txBody>
+          <a:bodyPr wrap="square" lIns="25400" tIns="25400" rIns="25400" bIns="25400" rtlCol="0" anchor="ctr"/>
+          <a:lstStyle/>
+          <a:p>
+            <a:pPr algn="ctr" indent="0" marL="0">
+              <a:buNone/>
+            </a:pPr>
+            <a:r>
+              <a:rPr lang="en-US" sz="1100" dirty="0">
+                <a:solidFill>
+                  <a:srgbClr val="14213D"/>
+                </a:solidFill>
+                <a:latin typeface="Calibri" pitchFamily="34" charset="0"/>
+                <a:ea typeface="Calibri" pitchFamily="34" charset="-122"/>
+                <a:cs typeface="Calibri" pitchFamily="34" charset="-120"/>
+              </a:rPr>
+              <a:t>Retime</a:t>
+            </a:r>
+            <a:endParaRPr lang="en-US" sz="1100" dirty="0"/>
+          </a:p>
+          <a:p>
+            <a:pPr algn="ctr" indent="0" marL="0">
+              <a:buNone/>
+            </a:pPr>
+            <a:r>
+              <a:rPr lang="en-US" sz="1100" dirty="0">
+                <a:solidFill>
+                  <a:srgbClr val="14213D"/>
+                </a:solidFill>
+                <a:latin typeface="Calibri" pitchFamily="34" charset="0"/>
+                <a:ea typeface="Calibri" pitchFamily="34" charset="-122"/>
+                <a:cs typeface="Calibri" pitchFamily="34" charset="-120"/>
+              </a:rPr>
+              <a:t>sensor → PC clock</a:t>
+            </a:r>
+            <a:endParaRPr lang="en-US" sz="1100" dirty="0"/>
+          </a:p>
+          <a:p>
+            <a:pPr algn="ctr" indent="0" marL="0">
+              <a:buNone/>
+            </a:pPr>
+            <a:r>
+              <a:rPr lang="en-US" sz="1100" dirty="0">
+                <a:solidFill>
+                  <a:srgbClr val="14213D"/>
+                </a:solidFill>
+                <a:latin typeface="Calibri" pitchFamily="34" charset="0"/>
+                <a:ea typeface="Calibri" pitchFamily="34" charset="-122"/>
+                <a:cs typeface="Calibri" pitchFamily="34" charset="-120"/>
+              </a:rPr>
+              <a:t>(clock fit)</a:t>
+            </a:r>
+            <a:endParaRPr lang="en-US" sz="1100" dirty="0"/>
+          </a:p>
+        </p:txBody>
+      </p:sp>
+      <p:sp>
+        <p:nvSpPr>
+          <p:cNvPr id="24" name="m2 GLIM"/>
+          <p:cNvSpPr/>
+          <p:nvPr/>
+        </p:nvSpPr>
+        <p:spPr>
+          <a:xfrm>
+            <a:off x="6117025" y="4595500"/>
+            <a:ext cx="1465692" cy="811768"/>
+          </a:xfrm>
+          <a:prstGeom prst="roundRect">
+            <a:avLst>
+              <a:gd name="adj" fmla="val 6759"/>
+            </a:avLst>
+          </a:prstGeom>
+          <a:solidFill>
+            <a:srgbClr val="FFFFFF"/>
+          </a:solidFill>
+          <a:ln w="15875">
+            <a:solidFill>
+              <a:srgbClr val="14213D"/>
+            </a:solidFill>
+          </a:ln>
+        </p:spPr>
+        <p:txBody>
+          <a:bodyPr wrap="square" lIns="25400" tIns="25400" rIns="25400" bIns="25400" rtlCol="0" anchor="ctr"/>
+          <a:lstStyle/>
+          <a:p>
+            <a:pPr algn="ctr" indent="0" marL="0">
+              <a:buNone/>
+            </a:pPr>
+            <a:r>
+              <a:rPr lang="en-US" sz="1100" dirty="0">
+                <a:solidFill>
+                  <a:srgbClr val="14213D"/>
+                </a:solidFill>
+                <a:latin typeface="Calibri" pitchFamily="34" charset="0"/>
+                <a:ea typeface="Calibri" pitchFamily="34" charset="-122"/>
+                <a:cs typeface="Calibri" pitchFamily="34" charset="-120"/>
+              </a:rPr>
+              <a:t>GLIM, own config</a:t>
+            </a:r>
+            <a:endParaRPr lang="en-US" sz="1100" dirty="0"/>
+          </a:p>
+          <a:p>
+            <a:pPr algn="ctr" indent="0" marL="0">
+              <a:buNone/>
+            </a:pPr>
+            <a:r>
+              <a:rPr lang="en-US" sz="1100" dirty="0">
+                <a:solidFill>
+                  <a:srgbClr val="14213D"/>
+                </a:solidFill>
+                <a:latin typeface="Calibri" pitchFamily="34" charset="0"/>
+                <a:ea typeface="Calibri" pitchFamily="34" charset="-122"/>
+                <a:cs typeface="Calibri" pitchFamily="34" charset="-120"/>
+              </a:rPr>
+              <a:t>+ pose-time</a:t>
+            </a:r>
+            <a:endParaRPr lang="en-US" sz="1100" dirty="0"/>
+          </a:p>
+          <a:p>
+            <a:pPr algn="ctr" indent="0" marL="0">
+              <a:buNone/>
+            </a:pPr>
+            <a:r>
+              <a:rPr lang="en-US" sz="1100" dirty="0">
+                <a:solidFill>
+                  <a:srgbClr val="14213D"/>
+                </a:solidFill>
+                <a:latin typeface="Calibri" pitchFamily="34" charset="0"/>
+                <a:ea typeface="Calibri" pitchFamily="34" charset="-122"/>
+                <a:cs typeface="Calibri" pitchFamily="34" charset="-120"/>
+              </a:rPr>
+              <a:t>correction +46 ms</a:t>
+            </a:r>
+            <a:endParaRPr lang="en-US" sz="1100" dirty="0"/>
+          </a:p>
+        </p:txBody>
+      </p:sp>
+      <p:sp>
+        <p:nvSpPr>
+          <p:cNvPr id="25" name="m2 trajectory"/>
+          <p:cNvSpPr/>
+          <p:nvPr/>
+        </p:nvSpPr>
+        <p:spPr>
+          <a:xfrm>
+            <a:off x="7808208" y="4595500"/>
+            <a:ext cx="1352946" cy="811768"/>
+          </a:xfrm>
+          <a:prstGeom prst="parallelogram">
+            <a:avLst/>
+          </a:prstGeom>
+          <a:solidFill>
+            <a:srgbClr val="FBE6D0"/>
+          </a:solidFill>
+          <a:ln w="19050">
+            <a:solidFill>
+              <a:srgbClr val="D9822B"/>
+            </a:solidFill>
+          </a:ln>
+        </p:spPr>
+        <p:txBody>
+          <a:bodyPr wrap="square" lIns="25400" tIns="25400" rIns="25400" bIns="25400" rtlCol="0" anchor="ctr"/>
+          <a:lstStyle/>
+          <a:p>
+            <a:pPr algn="ctr" indent="0" marL="0">
+              <a:buNone/>
+            </a:pPr>
+            <a:r>
+              <a:rPr lang="en-US" sz="1100" b="1" dirty="0">
+                <a:solidFill>
+                  <a:srgbClr val="14213D"/>
+                </a:solidFill>
+                <a:latin typeface="Calibri" pitchFamily="34" charset="0"/>
+                <a:ea typeface="Calibri" pitchFamily="34" charset="-122"/>
+                <a:cs typeface="Calibri" pitchFamily="34" charset="-120"/>
+              </a:rPr>
+              <a:t>LiDAR</a:t>
+            </a:r>
+            <a:endParaRPr lang="en-US" sz="1100" dirty="0"/>
+          </a:p>
+          <a:p>
+            <a:pPr algn="ctr" indent="0" marL="0">
+              <a:buNone/>
+            </a:pPr>
+            <a:r>
+              <a:rPr lang="en-US" sz="1100" b="1" dirty="0">
+                <a:solidFill>
+                  <a:srgbClr val="14213D"/>
+                </a:solidFill>
+                <a:latin typeface="Calibri" pitchFamily="34" charset="0"/>
+                <a:ea typeface="Calibri" pitchFamily="34" charset="-122"/>
+                <a:cs typeface="Calibri" pitchFamily="34" charset="-120"/>
+              </a:rPr>
+              <a:t>trajectory</a:t>
+            </a:r>
+            <a:endParaRPr lang="en-US" sz="1100" dirty="0"/>
+          </a:p>
+        </p:txBody>
+      </p:sp>
+      <p:sp>
+        <p:nvSpPr>
+          <p:cNvPr id="26" name="Arrow"/>
+          <p:cNvSpPr/>
+          <p:nvPr/>
+        </p:nvSpPr>
+        <p:spPr>
+          <a:xfrm>
+            <a:off x="2058186" y="5001384"/>
+            <a:ext cx="225491" cy="0"/>
+          </a:xfrm>
+          <a:prstGeom prst="line">
+            <a:avLst/>
+          </a:prstGeom>
+          <a:noFill/>
+          <a:ln w="15875">
+            <a:solidFill>
+              <a:srgbClr val="14213D"/>
+            </a:solidFill>
+            <a:prstDash val="solid"/>
+            <a:tailEnd type="triangle"/>
+          </a:ln>
+        </p:spPr>
+      </p:sp>
+      <p:sp>
+        <p:nvSpPr>
+          <p:cNvPr id="27" name="Arrow"/>
+          <p:cNvSpPr/>
+          <p:nvPr/>
+        </p:nvSpPr>
+        <p:spPr>
+          <a:xfrm>
+            <a:off x="3862115" y="5001384"/>
+            <a:ext cx="225491" cy="0"/>
+          </a:xfrm>
+          <a:prstGeom prst="line">
+            <a:avLst/>
+          </a:prstGeom>
+          <a:noFill/>
+          <a:ln w="15875">
+            <a:solidFill>
+              <a:srgbClr val="14213D"/>
+            </a:solidFill>
+            <a:prstDash val="solid"/>
+            <a:tailEnd type="triangle"/>
+          </a:ln>
+        </p:spPr>
+      </p:sp>
+      <p:sp>
+        <p:nvSpPr>
+          <p:cNvPr id="28" name="Arrow"/>
+          <p:cNvSpPr/>
+          <p:nvPr/>
+        </p:nvSpPr>
+        <p:spPr>
+          <a:xfrm>
+            <a:off x="5891534" y="5001384"/>
+            <a:ext cx="225491" cy="0"/>
+          </a:xfrm>
+          <a:prstGeom prst="line">
+            <a:avLst/>
+          </a:prstGeom>
+          <a:noFill/>
+          <a:ln w="15875">
+            <a:solidFill>
+              <a:srgbClr val="14213D"/>
+            </a:solidFill>
+            <a:prstDash val="solid"/>
+            <a:tailEnd type="triangle"/>
+          </a:ln>
+        </p:spPr>
+      </p:sp>
+      <p:sp>
+        <p:nvSpPr>
+          <p:cNvPr id="29" name="Arrow"/>
+          <p:cNvSpPr/>
+          <p:nvPr/>
+        </p:nvSpPr>
+        <p:spPr>
+          <a:xfrm>
+            <a:off x="7582717" y="5001384"/>
+            <a:ext cx="225491" cy="0"/>
+          </a:xfrm>
+          <a:prstGeom prst="line">
+            <a:avLst/>
+          </a:prstGeom>
+          <a:noFill/>
+          <a:ln w="15875">
+            <a:solidFill>
+              <a:srgbClr val="14213D"/>
+            </a:solidFill>
+            <a:prstDash val="solid"/>
+            <a:tailEnd type="triangle"/>
+          </a:ln>
+        </p:spPr>
+      </p:sp>
+      <p:sp>
+        <p:nvSpPr>
+          <p:cNvPr id="30" name="m2 realsense"/>
+          <p:cNvSpPr/>
+          <p:nvPr/>
+        </p:nvSpPr>
+        <p:spPr>
+          <a:xfrm>
+            <a:off x="660142" y="5632759"/>
+            <a:ext cx="1398044" cy="676473"/>
+          </a:xfrm>
+          <a:prstGeom prst="roundRect">
+            <a:avLst>
+              <a:gd name="adj" fmla="val 8110"/>
+            </a:avLst>
+          </a:prstGeom>
+          <a:solidFill>
+            <a:srgbClr val="FFFFFF"/>
+          </a:solidFill>
+          <a:ln w="15875">
+            <a:solidFill>
+              <a:srgbClr val="14213D"/>
+            </a:solidFill>
+          </a:ln>
+        </p:spPr>
+        <p:txBody>
+          <a:bodyPr wrap="square" lIns="25400" tIns="25400" rIns="25400" bIns="25400" rtlCol="0" anchor="ctr"/>
+          <a:lstStyle/>
+          <a:p>
+            <a:pPr algn="ctr" indent="0" marL="0">
+              <a:buNone/>
+            </a:pPr>
+            <a:r>
+              <a:rPr lang="en-US" sz="1100" dirty="0">
+                <a:solidFill>
+                  <a:srgbClr val="14213D"/>
+                </a:solidFill>
+                <a:latin typeface="Calibri" pitchFamily="34" charset="0"/>
+                <a:ea typeface="Calibri" pitchFamily="34" charset="-122"/>
+                <a:cs typeface="Calibri" pitchFamily="34" charset="-120"/>
+              </a:rPr>
+              <a:t>RealSense, IMU,</a:t>
+            </a:r>
+            <a:endParaRPr lang="en-US" sz="1100" dirty="0"/>
+          </a:p>
+          <a:p>
+            <a:pPr algn="ctr" indent="0" marL="0">
+              <a:buNone/>
+            </a:pPr>
+            <a:r>
+              <a:rPr lang="en-US" sz="1100" dirty="0">
+                <a:solidFill>
+                  <a:srgbClr val="14213D"/>
+                </a:solidFill>
+                <a:latin typeface="Calibri" pitchFamily="34" charset="0"/>
+                <a:ea typeface="Calibri" pitchFamily="34" charset="-122"/>
+                <a:cs typeface="Calibri" pitchFamily="34" charset="-120"/>
+              </a:rPr>
+              <a:t>Isaac VSLAM</a:t>
+            </a:r>
+            <a:endParaRPr lang="en-US" sz="1100" dirty="0"/>
+          </a:p>
+        </p:txBody>
+      </p:sp>
+      <p:sp>
+        <p:nvSpPr>
+          <p:cNvPr id="31" name="m2 copy"/>
+          <p:cNvSpPr/>
+          <p:nvPr/>
+        </p:nvSpPr>
+        <p:spPr>
+          <a:xfrm>
+            <a:off x="2283677" y="5632759"/>
+            <a:ext cx="3607857" cy="676473"/>
+          </a:xfrm>
+          <a:prstGeom prst="roundRect">
+            <a:avLst>
+              <a:gd name="adj" fmla="val 8110"/>
+            </a:avLst>
+          </a:prstGeom>
+          <a:solidFill>
+            <a:srgbClr val="FFFFFF"/>
+          </a:solidFill>
+          <a:ln w="15875">
+            <a:solidFill>
+              <a:srgbClr val="14213D"/>
+            </a:solidFill>
+          </a:ln>
+        </p:spPr>
+        <p:txBody>
+          <a:bodyPr wrap="square" lIns="25400" tIns="25400" rIns="25400" bIns="25400" rtlCol="0" anchor="ctr"/>
+          <a:lstStyle/>
+          <a:p>
+            <a:pPr algn="ctr" indent="0" marL="0">
+              <a:buNone/>
+            </a:pPr>
+            <a:r>
+              <a:rPr lang="en-US" sz="1100" dirty="0">
+                <a:solidFill>
+                  <a:srgbClr val="14213D"/>
+                </a:solidFill>
+                <a:latin typeface="Calibri" pitchFamily="34" charset="0"/>
+                <a:ea typeface="Calibri" pitchFamily="34" charset="-122"/>
+                <a:cs typeface="Calibri" pitchFamily="34" charset="-120"/>
+              </a:rPr>
+              <a:t>copied as recorded: already on the PC clock;</a:t>
+            </a:r>
+            <a:endParaRPr lang="en-US" sz="1100" dirty="0"/>
+          </a:p>
+          <a:p>
+            <a:pPr algn="ctr" indent="0" marL="0">
+              <a:buNone/>
+            </a:pPr>
+            <a:r>
+              <a:rPr lang="en-US" sz="1100" dirty="0">
+                <a:solidFill>
+                  <a:srgbClr val="14213D"/>
+                </a:solidFill>
+                <a:latin typeface="Calibri" pitchFamily="34" charset="0"/>
+                <a:ea typeface="Calibri" pitchFamily="34" charset="-122"/>
+                <a:cs typeface="Calibri" pitchFamily="34" charset="-120"/>
+              </a:rPr>
+              <a:t>frames renamed per robot</a:t>
+            </a:r>
+            <a:endParaRPr lang="en-US" sz="1100" dirty="0"/>
+          </a:p>
+        </p:txBody>
+      </p:sp>
+      <p:sp>
+        <p:nvSpPr>
+          <p:cNvPr id="32" name="Arrow"/>
+          <p:cNvSpPr/>
+          <p:nvPr/>
+        </p:nvSpPr>
+        <p:spPr>
+          <a:xfrm>
+            <a:off x="2058186" y="5970995"/>
+            <a:ext cx="225491" cy="0"/>
+          </a:xfrm>
+          <a:prstGeom prst="line">
+            <a:avLst/>
+          </a:prstGeom>
+          <a:noFill/>
+          <a:ln w="15875">
+            <a:solidFill>
+              <a:srgbClr val="14213D"/>
+            </a:solidFill>
+            <a:prstDash val="solid"/>
+            <a:tailEnd type="triangle"/>
+          </a:ln>
+        </p:spPr>
+      </p:sp>
+      <p:sp>
+        <p:nvSpPr>
+          <p:cNvPr id="33" name="pass lane"/>
+          <p:cNvSpPr/>
+          <p:nvPr/>
+        </p:nvSpPr>
+        <p:spPr>
+          <a:xfrm>
+            <a:off x="9521940" y="1393527"/>
+            <a:ext cx="2142165" cy="5050999"/>
+          </a:xfrm>
+          <a:prstGeom prst="roundRect">
+            <a:avLst>
+              <a:gd name="adj" fmla="val 4269"/>
+            </a:avLst>
+          </a:prstGeom>
+          <a:solidFill>
+            <a:srgbClr val="EEF1F5"/>
+          </a:solidFill>
+          <a:ln w="12700">
+            <a:solidFill>
+              <a:srgbClr val="A7B0C0"/>
+            </a:solidFill>
+            <a:prstDash val="solid"/>
+          </a:ln>
+        </p:spPr>
+      </p:sp>
+      <p:sp>
+        <p:nvSpPr>
+          <p:cNvPr id="34" name="pass lane title"/>
+          <p:cNvSpPr txBox="1"/>
+          <p:nvPr/>
+        </p:nvSpPr>
+        <p:spPr>
+          <a:xfrm>
+            <a:off x="9657234" y="1457535"/>
+            <a:ext cx="1871576" cy="274320"/>
+          </a:xfrm>
+          <a:prstGeom prst="rect">
+            <a:avLst/>
+          </a:prstGeom>
+          <a:noFill/>
+          <a:ln/>
+        </p:spPr>
+        <p:txBody>
+          <a:bodyPr wrap="square" lIns="0" tIns="0" rIns="0" bIns="0" rtlCol="0" anchor="ctr"/>
+          <a:lstStyle/>
+          <a:p>
+            <a:pPr indent="0" marL="0">
+              <a:buNone/>
+            </a:pPr>
+            <a:r>
+              <a:rPr lang="en-US" sz="1300" b="1" dirty="0">
+                <a:solidFill>
+                  <a:srgbClr val="14213D"/>
+                </a:solidFill>
+                <a:latin typeface="Calibri" pitchFamily="34" charset="0"/>
+                <a:ea typeface="Calibri" pitchFamily="34" charset="-122"/>
+                <a:cs typeface="Calibri" pitchFamily="34" charset="-120"/>
+              </a:rPr>
+              <a:t>Each pass</a:t>
+            </a:r>
+            <a:endParaRPr lang="en-US" sz="1300" dirty="0"/>
+          </a:p>
+        </p:txBody>
+      </p:sp>
+      <p:sp>
+        <p:nvSpPr>
+          <p:cNvPr id="35" name="merge"/>
+          <p:cNvSpPr/>
+          <p:nvPr/>
+        </p:nvSpPr>
+        <p:spPr>
+          <a:xfrm>
+            <a:off x="9612136" y="2960690"/>
+            <a:ext cx="1961772" cy="1465692"/>
+          </a:xfrm>
+          <a:prstGeom prst="roundRect">
+            <a:avLst>
+              <a:gd name="adj" fmla="val 3743"/>
+            </a:avLst>
+          </a:prstGeom>
+          <a:solidFill>
+            <a:srgbClr val="FFFFFF"/>
+          </a:solidFill>
+          <a:ln w="15875">
+            <a:solidFill>
+              <a:srgbClr val="14213D"/>
+            </a:solidFill>
+          </a:ln>
+        </p:spPr>
+        <p:txBody>
+          <a:bodyPr wrap="square" lIns="25400" tIns="25400" rIns="25400" bIns="25400" rtlCol="0" anchor="ctr"/>
+          <a:lstStyle/>
+          <a:p>
+            <a:pPr algn="ctr" indent="0" marL="0">
+              <a:buNone/>
+            </a:pPr>
+            <a:r>
+              <a:rPr lang="en-US" sz="1100" dirty="0">
+                <a:solidFill>
+                  <a:srgbClr val="14213D"/>
+                </a:solidFill>
+                <a:latin typeface="Calibri" pitchFamily="34" charset="0"/>
+                <a:ea typeface="Calibri" pitchFamily="34" charset="-122"/>
+                <a:cs typeface="Calibri" pitchFamily="34" charset="-120"/>
+              </a:rPr>
+              <a:t>Merge</a:t>
+            </a:r>
+            <a:endParaRPr lang="en-US" sz="1100" dirty="0"/>
+          </a:p>
+          <a:p>
+            <a:pPr algn="ctr" indent="0" marL="0">
+              <a:buNone/>
+            </a:pPr>
+            <a:r>
+              <a:rPr lang="en-US" sz="1100" dirty="0">
+                <a:solidFill>
+                  <a:srgbClr val="14213D"/>
+                </a:solidFill>
+                <a:latin typeface="Calibri" pitchFamily="34" charset="0"/>
+                <a:ea typeface="Calibri" pitchFamily="34" charset="-122"/>
+                <a:cs typeface="Calibri" pitchFamily="34" charset="-120"/>
+              </a:rPr>
+              <a:t>every robot's</a:t>
+            </a:r>
+            <a:endParaRPr lang="en-US" sz="1100" dirty="0"/>
+          </a:p>
+          <a:p>
+            <a:pPr algn="ctr" indent="0" marL="0">
+              <a:buNone/>
+            </a:pPr>
+            <a:r>
+              <a:rPr lang="en-US" sz="1100" dirty="0">
+                <a:solidFill>
+                  <a:srgbClr val="14213D"/>
+                </a:solidFill>
+                <a:latin typeface="Calibri" pitchFamily="34" charset="0"/>
+                <a:ea typeface="Calibri" pitchFamily="34" charset="-122"/>
+                <a:cs typeface="Calibri" pitchFamily="34" charset="-120"/>
+              </a:rPr>
+              <a:t>retimed + ZED bags,</a:t>
+            </a:r>
+            <a:endParaRPr lang="en-US" sz="1100" dirty="0"/>
+          </a:p>
+          <a:p>
+            <a:pPr algn="ctr" indent="0" marL="0">
+              <a:buNone/>
+            </a:pPr>
+            <a:r>
+              <a:rPr lang="en-US" sz="1100" dirty="0">
+                <a:solidFill>
+                  <a:srgbClr val="14213D"/>
+                </a:solidFill>
+                <a:latin typeface="Calibri" pitchFamily="34" charset="0"/>
+                <a:ea typeface="Calibri" pitchFamily="34" charset="-122"/>
+                <a:cs typeface="Calibri" pitchFamily="34" charset="-120"/>
+              </a:rPr>
+              <a:t>checked against</a:t>
+            </a:r>
+            <a:endParaRPr lang="en-US" sz="1100" dirty="0"/>
+          </a:p>
+          <a:p>
+            <a:pPr algn="ctr" indent="0" marL="0">
+              <a:buNone/>
+            </a:pPr>
+            <a:r>
+              <a:rPr lang="en-US" sz="1100" dirty="0">
+                <a:solidFill>
+                  <a:srgbClr val="14213D"/>
+                </a:solidFill>
+                <a:latin typeface="Calibri" pitchFamily="34" charset="0"/>
+                <a:ea typeface="Calibri" pitchFamily="34" charset="-122"/>
+                <a:cs typeface="Calibri" pitchFamily="34" charset="-120"/>
+              </a:rPr>
+              <a:t>record.yaml;</a:t>
+            </a:r>
+            <a:endParaRPr lang="en-US" sz="1100" dirty="0"/>
+          </a:p>
+          <a:p>
+            <a:pPr algn="ctr" indent="0" marL="0">
+              <a:buNone/>
+            </a:pPr>
+            <a:r>
+              <a:rPr lang="en-US" sz="1100" dirty="0">
+                <a:solidFill>
+                  <a:srgbClr val="14213D"/>
+                </a:solidFill>
+                <a:latin typeface="Calibri" pitchFamily="34" charset="0"/>
+                <a:ea typeface="Calibri" pitchFamily="34" charset="-122"/>
+                <a:cs typeface="Calibri" pitchFamily="34" charset="-120"/>
+              </a:rPr>
+              <a:t>calibrations</a:t>
+            </a:r>
+            <a:endParaRPr lang="en-US" sz="1100" dirty="0"/>
+          </a:p>
+          <a:p>
+            <a:pPr algn="ctr" indent="0" marL="0">
+              <a:buNone/>
+            </a:pPr>
+            <a:r>
+              <a:rPr lang="en-US" sz="1100" dirty="0">
+                <a:solidFill>
+                  <a:srgbClr val="14213D"/>
+                </a:solidFill>
+                <a:latin typeface="Calibri" pitchFamily="34" charset="0"/>
+                <a:ea typeface="Calibri" pitchFamily="34" charset="-122"/>
+                <a:cs typeface="Calibri" pitchFamily="34" charset="-120"/>
+              </a:rPr>
+              <a:t>to /tf_static</a:t>
+            </a:r>
+            <a:endParaRPr lang="en-US" sz="1100" dirty="0"/>
+          </a:p>
+        </p:txBody>
+      </p:sp>
+      <p:sp>
+        <p:nvSpPr>
+          <p:cNvPr id="36" name="merged bag"/>
+          <p:cNvSpPr/>
+          <p:nvPr/>
+        </p:nvSpPr>
+        <p:spPr>
+          <a:xfrm>
+            <a:off x="9612136" y="4911188"/>
+            <a:ext cx="1961772" cy="721571"/>
+          </a:xfrm>
+          <a:prstGeom prst="parallelogram">
+            <a:avLst/>
+          </a:prstGeom>
+          <a:solidFill>
+            <a:srgbClr val="FBE6D0"/>
+          </a:solidFill>
+          <a:ln w="19050">
+            <a:solidFill>
+              <a:srgbClr val="D9822B"/>
+            </a:solidFill>
+          </a:ln>
+        </p:spPr>
+        <p:txBody>
+          <a:bodyPr wrap="square" lIns="25400" tIns="25400" rIns="25400" bIns="25400" rtlCol="0" anchor="ctr"/>
+          <a:lstStyle/>
+          <a:p>
+            <a:pPr algn="ctr" indent="0" marL="0">
+              <a:buNone/>
+            </a:pPr>
+            <a:r>
+              <a:rPr lang="en-US" sz="1100" b="1" dirty="0">
+                <a:solidFill>
+                  <a:srgbClr val="14213D"/>
+                </a:solidFill>
+                <a:latin typeface="Calibri" pitchFamily="34" charset="0"/>
+                <a:ea typeface="Calibri" pitchFamily="34" charset="-122"/>
+                <a:cs typeface="Calibri" pitchFamily="34" charset="-120"/>
+              </a:rPr>
+              <a:t>Merged bag</a:t>
+            </a:r>
+            <a:endParaRPr lang="en-US" sz="1100" dirty="0"/>
+          </a:p>
+        </p:txBody>
+      </p:sp>
+      <p:sp>
+        <p:nvSpPr>
+          <p:cNvPr id="37" name="to merged bag"/>
+          <p:cNvSpPr/>
+          <p:nvPr/>
+        </p:nvSpPr>
+        <p:spPr>
+          <a:xfrm>
+            <a:off x="10593022" y="4426382"/>
+            <a:ext cx="0" cy="484806"/>
+          </a:xfrm>
+          <a:prstGeom prst="line">
+            <a:avLst/>
+          </a:prstGeom>
+          <a:noFill/>
+          <a:ln w="15875">
+            <a:solidFill>
+              <a:srgbClr val="14213D"/>
+            </a:solidFill>
+            <a:prstDash val="solid"/>
+            <a:tailEnd type="triangle"/>
+          </a:ln>
+        </p:spPr>
+      </p:sp>
+      <p:sp>
+        <p:nvSpPr>
+          <p:cNvPr id="38" name="mobile_1 bags"/>
+          <p:cNvSpPr/>
+          <p:nvPr/>
+        </p:nvSpPr>
+        <p:spPr>
+          <a:xfrm>
+            <a:off x="9093507" y="2385688"/>
+            <a:ext cx="518629" cy="969611"/>
+          </a:xfrm>
+          <a:prstGeom prst="line">
+            <a:avLst/>
+          </a:prstGeom>
+          <a:noFill/>
+          <a:ln w="15875">
+            <a:solidFill>
+              <a:srgbClr val="14213D"/>
+            </a:solidFill>
+            <a:prstDash val="solid"/>
+            <a:tailEnd type="triangle"/>
+          </a:ln>
+        </p:spPr>
+      </p:sp>
+      <p:sp>
+        <p:nvSpPr>
+          <p:cNvPr id="39" name="mobile_2 bags"/>
+          <p:cNvSpPr/>
+          <p:nvPr/>
+        </p:nvSpPr>
+        <p:spPr>
+          <a:xfrm flipV="1">
+            <a:off x="9093507" y="4031772"/>
+            <a:ext cx="518629" cy="969611"/>
+          </a:xfrm>
+          <a:prstGeom prst="line">
+            <a:avLst/>
+          </a:prstGeom>
+          <a:noFill/>
+          <a:ln w="15875">
+            <a:solidFill>
+              <a:srgbClr val="14213D"/>
+            </a:solidFill>
+            <a:prstDash val="solid"/>
+            <a:tailEnd type="triangle"/>
+          </a:ln>
+        </p:spPr>
+      </p:sp>
+      <p:sp>
+        <p:nvSpPr>
+          <p:cNvPr id="40" name="single robot note"/>
+          <p:cNvSpPr txBox="1"/>
+          <p:nvPr/>
+        </p:nvSpPr>
+        <p:spPr>
+          <a:xfrm>
+            <a:off x="9612136" y="5869524"/>
+            <a:ext cx="1961772" cy="563728"/>
+          </a:xfrm>
+          <a:prstGeom prst="rect">
+            <a:avLst/>
+          </a:prstGeom>
+          <a:noFill/>
+          <a:ln/>
+        </p:spPr>
+        <p:txBody>
+          <a:bodyPr wrap="square" lIns="0" tIns="0" rIns="0" bIns="0" rtlCol="0" anchor="ctr"/>
+          <a:lstStyle/>
+          <a:p>
+            <a:pPr algn="ctr" indent="0" marL="0">
+              <a:buNone/>
+            </a:pPr>
+            <a:r>
+              <a:rPr lang="en-US" sz="950" i="1" dirty="0">
+                <a:solidFill>
+                  <a:srgbClr val="5A6475"/>
+                </a:solidFill>
+                <a:latin typeface="Calibri" pitchFamily="34" charset="0"/>
+                <a:ea typeface="Calibri" pitchFamily="34" charset="-122"/>
+                <a:cs typeface="Calibri" pitchFamily="34" charset="-120"/>
+              </a:rPr>
+              <a:t>one robot alone (20261015):</a:t>
+            </a:r>
+            <a:endParaRPr lang="en-US" sz="950" dirty="0"/>
+          </a:p>
+          <a:p>
+            <a:pPr algn="ctr" indent="0" marL="0">
+              <a:buNone/>
+            </a:pPr>
+            <a:r>
+              <a:rPr lang="en-US" sz="950" i="1" dirty="0">
+                <a:solidFill>
+                  <a:srgbClr val="5A6475"/>
+                </a:solidFill>
+                <a:latin typeface="Calibri" pitchFamily="34" charset="0"/>
+                <a:ea typeface="Calibri" pitchFamily="34" charset="-122"/>
+                <a:cs typeface="Calibri" pitchFamily="34" charset="-120"/>
+              </a:rPr>
+              <a:t>its own retimed bag, no merge</a:t>
+            </a:r>
+            <a:endParaRPr lang="en-US" sz="950" dirty="0"/>
+          </a:p>
+        </p:txBody>
+      </p:sp>
+      <p:sp>
+        <p:nvSpPr>
+          <p:cNvPr id="41" name="to next"/>
+          <p:cNvSpPr txBox="1"/>
+          <p:nvPr/>
+        </p:nvSpPr>
+        <p:spPr>
+          <a:xfrm>
+            <a:off x="4087606" y="3834468"/>
+            <a:ext cx="5073548" cy="180393"/>
+          </a:xfrm>
+          <a:prstGeom prst="rect">
+            <a:avLst/>
+          </a:prstGeom>
+          <a:noFill/>
+          <a:ln/>
+        </p:spPr>
+        <p:txBody>
+          <a:bodyPr wrap="square" lIns="0" tIns="0" rIns="0" bIns="0" rtlCol="0" anchor="ctr"/>
+          <a:lstStyle/>
+          <a:p>
+            <a:pPr algn="r" indent="0" marL="0">
+              <a:buNone/>
+            </a:pPr>
+            <a:r>
+              <a:rPr lang="en-US" sz="950" i="1" dirty="0">
+                <a:solidFill>
+                  <a:srgbClr val="5A6475"/>
+                </a:solidFill>
+                <a:latin typeface="Calibri" pitchFamily="34" charset="0"/>
+                <a:ea typeface="Calibri" pitchFamily="34" charset="-122"/>
+                <a:cs typeface="Calibri" pitchFamily="34" charset="-120"/>
+              </a:rPr>
+              <a:t>trajectories → the mapping session or the sequence (next slide)</a:t>
+            </a:r>
+            <a:endParaRPr lang="en-US" sz="950" dirty="0"/>
+          </a:p>
+        </p:txBody>
+      </p:sp>
+    </p:spTree>
+  </p:cSld>
+  <p:clrMapOvr>
+    <a:masterClrMapping/>
+  </p:clrMapOvr>
+</p:sld>
+</file>
+
+<file path=ppt/slides/slide2.xml><?xml version="1.0" encoding="utf-8"?>
+<p:sld xmlns:a="http://schemas.openxmlformats.org/drawingml/2006/main" xmlns:r="http://schemas.openxmlformats.org/officeDocument/2006/relationships" xmlns:p="http://schemas.openxmlformats.org/presentationml/2006/main">
+  <p:cSld name="Slide 2">
+    <p:bg>
+      <p:bgPr>
+        <a:solidFill>
+          <a:srgbClr val="FFFFFF"/>
+        </a:solidFill>
+      </p:bgPr>
+    </p:bg>
+    <p:spTree>
+      <p:nvGrpSpPr>
+        <p:cNvPr id="1" name=""/>
+        <p:cNvGrpSpPr/>
+        <p:nvPr/>
+      </p:nvGrpSpPr>
+      <p:grpSpPr>
+        <a:xfrm>
+          <a:off x="0" y="0"/>
+          <a:ext cx="0" cy="0"/>
+          <a:chOff x="0" y="0"/>
+          <a:chExt cx="0" cy="0"/>
+        </a:xfrm>
+      </p:grpSpPr>
+      <p:sp>
+        <p:nvSpPr>
+          <p:cNvPr id="2" name="Title"/>
+          <p:cNvSpPr txBox="1"/>
+          <p:nvPr/>
+        </p:nvSpPr>
+        <p:spPr>
+          <a:xfrm>
+            <a:off x="457200" y="365760"/>
+            <a:ext cx="11247120" cy="640080"/>
+          </a:xfrm>
+          <a:prstGeom prst="rect">
+            <a:avLst/>
+          </a:prstGeom>
+          <a:noFill/>
+          <a:ln/>
+        </p:spPr>
+        <p:txBody>
+          <a:bodyPr wrap="square" lIns="0" tIns="0" rIns="0" bIns="0" rtlCol="0" anchor="ctr"/>
+          <a:lstStyle/>
+          <a:p>
+            <a:pPr indent="0" marL="0">
+              <a:buNone/>
+            </a:pPr>
+            <a:r>
+              <a:rPr lang="en-US" sz="3200" b="1" dirty="0">
+                <a:solidFill>
+                  <a:srgbClr val="14213D"/>
+                </a:solidFill>
+                <a:latin typeface="Cambria" pitchFamily="34" charset="0"/>
+                <a:ea typeface="Cambria" pitchFamily="34" charset="-122"/>
+                <a:cs typeface="Cambria" pitchFamily="34" charset="-120"/>
+              </a:rPr>
               <a:t>Reference pipeline</a:t>
             </a:r>
-            <a:endParaRPr lang="en-US" sz="3600" dirty="0"/>
+            <a:endParaRPr lang="en-US" sz="3200" dirty="0"/>
           </a:p>
         </p:txBody>
       </p:sp>
@@ -949,8 +3005,8 @@
         </p:nvSpPr>
         <p:spPr>
           <a:xfrm>
-            <a:off x="660142" y="1740999"/>
-            <a:ext cx="5486400" cy="292608"/>
+            <a:off x="660142" y="1731855"/>
+            <a:ext cx="10868668" cy="274320"/>
           </a:xfrm>
           <a:prstGeom prst="rect">
             <a:avLst/>
@@ -966,7 +3022,7 @@
               <a:buNone/>
             </a:pPr>
             <a:r>
-              <a:rPr lang="en-US" sz="1400" b="1" dirty="0">
+              <a:rPr lang="en-US" sz="1300" b="1" dirty="0">
                 <a:solidFill>
                   <a:srgbClr val="14213D"/>
                 </a:solidFill>
@@ -976,7 +3032,7 @@
               </a:rPr>
               <a:t>Mapping session (once per site)</a:t>
             </a:r>
-            <a:endParaRPr lang="en-US" sz="1400" dirty="0"/>
+            <a:endParaRPr lang="en-US" sz="1300" dirty="0"/>
           </a:p>
         </p:txBody>
       </p:sp>
@@ -1021,7 +3077,7 @@
                 <a:ea typeface="Calibri" pitchFamily="34" charset="-122"/>
                 <a:cs typeface="Calibri" pitchFamily="34" charset="-120"/>
               </a:rPr>
-              <a:t>Mapping</a:t>
+              <a:t>Processed</a:t>
             </a:r>
             <a:endParaRPr lang="en-US" sz="1200" dirty="0"/>
           </a:p>
@@ -1394,7 +3450,7 @@
       </p:sp>
       <p:sp>
         <p:nvSpPr>
-          <p:cNvPr id="12" name="Arrow 1"/>
+          <p:cNvPr id="12" name="Arrow"/>
           <p:cNvSpPr/>
           <p:nvPr/>
         </p:nvSpPr>
@@ -1418,7 +3474,7 @@
       </p:sp>
       <p:sp>
         <p:nvSpPr>
-          <p:cNvPr id="13" name="Arrow 2"/>
+          <p:cNvPr id="13" name="Arrow"/>
           <p:cNvSpPr/>
           <p:nvPr/>
         </p:nvSpPr>
@@ -1442,7 +3498,7 @@
       </p:sp>
       <p:sp>
         <p:nvSpPr>
-          <p:cNvPr id="14" name="Arrow 3"/>
+          <p:cNvPr id="14" name="Arrow"/>
           <p:cNvSpPr/>
           <p:nvPr/>
         </p:nvSpPr>
@@ -1466,7 +3522,7 @@
       </p:sp>
       <p:sp>
         <p:nvSpPr>
-          <p:cNvPr id="15" name="Arrow 4"/>
+          <p:cNvPr id="15" name="Arrow"/>
           <p:cNvSpPr/>
           <p:nvPr/>
         </p:nvSpPr>
@@ -1581,7 +3637,7 @@
           <a:bodyPr wrap="square" lIns="0" tIns="0" rIns="0" bIns="0" rtlCol="0" anchor="ctr"/>
           <a:lstStyle/>
           <a:p>
-            <a:pPr indent="0" marL="0">
+            <a:pPr algn="l" indent="0" marL="0">
               <a:buNone/>
             </a:pPr>
             <a:r>
@@ -1682,8 +3738,8 @@
         </p:nvSpPr>
         <p:spPr>
           <a:xfrm>
-            <a:off x="660142" y="4198852"/>
-            <a:ext cx="5486400" cy="292608"/>
+            <a:off x="660142" y="4189708"/>
+            <a:ext cx="10868668" cy="274320"/>
           </a:xfrm>
           <a:prstGeom prst="rect">
             <a:avLst/>
@@ -1699,7 +3755,7 @@
               <a:buNone/>
             </a:pPr>
             <a:r>
-              <a:rPr lang="en-US" sz="1400" b="1" dirty="0">
+              <a:rPr lang="en-US" sz="1300" b="1" dirty="0">
                 <a:solidFill>
                   <a:srgbClr val="14213D"/>
                 </a:solidFill>
@@ -1709,7 +3765,7 @@
               </a:rPr>
               <a:t>Every sequence</a:t>
             </a:r>
-            <a:endParaRPr lang="en-US" sz="1400" dirty="0"/>
+            <a:endParaRPr lang="en-US" sz="1300" dirty="0"/>
           </a:p>
         </p:txBody>
       </p:sp>
@@ -1754,7 +3810,7 @@
                 <a:ea typeface="Calibri" pitchFamily="34" charset="-122"/>
                 <a:cs typeface="Calibri" pitchFamily="34" charset="-120"/>
               </a:rPr>
-              <a:t>Sequence</a:t>
+              <a:t>Processed</a:t>
             </a:r>
             <a:endParaRPr lang="en-US" sz="1200" dirty="0"/>
           </a:p>
@@ -2129,7 +4185,7 @@
       </p:sp>
       <p:sp>
         <p:nvSpPr>
-          <p:cNvPr id="29" name="Arrow 5"/>
+          <p:cNvPr id="29" name="Arrow"/>
           <p:cNvSpPr/>
           <p:nvPr/>
         </p:nvSpPr>
@@ -2153,7 +4209,7 @@
       </p:sp>
       <p:sp>
         <p:nvSpPr>
-          <p:cNvPr id="30" name="Arrow 6"/>
+          <p:cNvPr id="30" name="Arrow"/>
           <p:cNvSpPr/>
           <p:nvPr/>
         </p:nvSpPr>
@@ -2177,7 +4233,7 @@
       </p:sp>
       <p:sp>
         <p:nvSpPr>
-          <p:cNvPr id="31" name="Arrow 7"/>
+          <p:cNvPr id="31" name="Arrow"/>
           <p:cNvSpPr/>
           <p:nvPr/>
         </p:nvSpPr>
@@ -2201,7 +4257,7 @@
       </p:sp>
       <p:sp>
         <p:nvSpPr>
-          <p:cNvPr id="32" name="Arrow 8"/>
+          <p:cNvPr id="32" name="Arrow"/>
           <p:cNvSpPr/>
           <p:nvPr/>
         </p:nvSpPr>
@@ -2225,7 +4281,7 @@
       </p:sp>
       <p:sp>
         <p:nvSpPr>
-          <p:cNvPr id="33" name="Arrow 9"/>
+          <p:cNvPr id="33" name="Arrow"/>
           <p:cNvSpPr/>
           <p:nvPr/>
         </p:nvSpPr>
@@ -2361,7 +4417,7 @@
           <a:ln/>
         </p:spPr>
         <p:txBody>
-          <a:bodyPr wrap="square" lIns="0" tIns="0" rIns="0" bIns="0" rtlCol="0" anchor="b"/>
+          <a:bodyPr wrap="square" lIns="0" tIns="0" rIns="0" bIns="0" rtlCol="0" anchor="ctr"/>
           <a:lstStyle/>
           <a:p>
             <a:pPr algn="ctr" indent="0" marL="0">

</xml_diff>

<commit_message>
Method figure: what pose-time correction, plane BA and TSDF fusion do to a wall
figs/src/refmethod.py simulates a room seen from above and shows one wall
before and after each mapping step (2-D plane BA as in 02_bundle_adjust,
TSDF as in 01_build_map); added as slide 3 of the pipeline PPT.

Co-Authored-By: Claude Opus 5.5 <noreply@anthropic.com>
Claude-Session: https://claude.ai/code/session_01VemgbrpoRNyLKBeEk6r3sF
</commit_message>
<xml_diff>
--- a/scoop_testbed_paper/figs/fig_refpipeline.pptx
+++ b/scoop_testbed_paper/figs/fig_refpipeline.pptx
@@ -7,9 +7,10 @@
   <p:sldIdLst>
     <p:sldId id="256" r:id="rId2"/>
     <p:sldId id="257" r:id="rId3"/>
+    <p:sldId id="258" r:id="rId4"/>
   </p:sldIdLst>
   <p:notesMasterIdLst>
-    <p:notesMasterId r:id="rId4"/>
+    <p:notesMasterId r:id="rId5"/>
   </p:notesMasterIdLst>
   <p:sldSz cx="12192000" cy="6858000"/>
   <p:notesSz cx="6858000" cy="12192000"/>
@@ -633,6 +634,94 @@
 </p:notes>
 </file>
 
+<file path=ppt/notesSlides/notesSlide3.xml><?xml version="1.0" encoding="utf-8"?>
+<p:notes xmlns:a="http://schemas.openxmlformats.org/drawingml/2006/main" xmlns:r="http://schemas.openxmlformats.org/officeDocument/2006/relationships" xmlns:p="http://schemas.openxmlformats.org/presentationml/2006/main">
+  <p:cSld>
+    <p:spTree>
+      <p:nvGrpSpPr>
+        <p:cNvPr id="1" name=""/>
+        <p:cNvGrpSpPr/>
+        <p:nvPr/>
+      </p:nvGrpSpPr>
+      <p:grpSpPr>
+        <a:xfrm>
+          <a:off x="0" y="0"/>
+          <a:ext cx="0" cy="0"/>
+          <a:chOff x="0" y="0"/>
+          <a:chExt cx="0" cy="0"/>
+        </a:xfrm>
+      </p:grpSpPr>
+      <p:sp>
+        <p:nvSpPr>
+          <p:cNvPr id="2" name="Slide Image Placeholder 1"/>
+          <p:cNvSpPr>
+            <a:spLocks noGrp="1" noRot="1" noChangeAspect="1"/>
+          </p:cNvSpPr>
+          <p:nvPr>
+            <p:ph type="sldImg"/>
+          </p:nvPr>
+        </p:nvSpPr>
+        <p:spPr/>
+      </p:sp>
+      <p:sp>
+        <p:nvSpPr>
+          <p:cNvPr id="3" name="Notes Placeholder 2"/>
+          <p:cNvSpPr>
+            <a:spLocks noGrp="1"/>
+          </p:cNvSpPr>
+          <p:nvPr>
+            <p:ph type="body" idx="1"/>
+          </p:nvPr>
+        </p:nvSpPr>
+        <p:spPr/>
+        <p:txBody>
+          <a:bodyPr/>
+          <a:lstStyle/>
+          <a:p>
+            <a:r>
+              <a:rPr lang="en-US" dirty="0"/>
+              <a:t>One wall, seen from above, before and after each step; the shaded bars are the 5-95 % spread of each 0.25 m patch, the wall thickness. (a) GLIM writes each pose with the start of its sweep, 50 ms before the scan's middle; while turning, the scans land off the wall. Moving the poses 46 ms on export leaves 4 ms and the wall is as thin as the sensor. (b) Small odometry drift places the same wall differently on each visit; plane bundle adjustment moves all keyframes together until every plane is as thin as the scans allow. (c) The union keeps every cell any scan hit, so the band grows with every pass; the TSDF averages the rays' signed distances and keeps one surface at their mean. This is a simulation: its walls are perfect planes, so the TSDF comes out thinner than on the real map (7.8 cm against 12.8 cm for the union on 20261015).</a:t>
+            </a:r>
+            <a:endParaRPr lang="en-US" dirty="0"/>
+          </a:p>
+        </p:txBody>
+      </p:sp>
+      <p:sp>
+        <p:nvSpPr>
+          <p:cNvPr id="4" name="Slide Number Placeholder 3"/>
+          <p:cNvSpPr>
+            <a:spLocks noGrp="1"/>
+          </p:cNvSpPr>
+          <p:nvPr>
+            <p:ph type="sldNum" sz="quarter" idx="10"/>
+          </p:nvPr>
+        </p:nvSpPr>
+        <p:spPr/>
+        <p:txBody>
+          <a:bodyPr/>
+          <a:lstStyle/>
+          <a:p>
+            <a:fld id="{F7021451-1387-4CA6-816F-3879F97B5CBC}" type="slidenum">
+              <a:rPr lang="en-US"/>
+              <a:t>3</a:t>
+            </a:fld>
+            <a:endParaRPr lang="en-US"/>
+          </a:p>
+        </p:txBody>
+      </p:sp>
+    </p:spTree>
+    <p:extLst>
+      <p:ext uri="{BB962C8B-B14F-4D97-AF65-F5344CB8AC3E}">
+        <p14:creationId xmlns:p14="http://schemas.microsoft.com/office/powerpoint/2010/main" val="1024086991"/>
+      </p:ext>
+    </p:extLst>
+  </p:cSld>
+  <p:clrMapOvr>
+    <a:masterClrMapping/>
+  </p:clrMapOvr>
+</p:notes>
+</file>
+
 <file path=ppt/slideLayouts/slideLayout1.xml><?xml version="1.0" encoding="utf-8"?>
 <p:sldLayout xmlns:a="http://schemas.openxmlformats.org/drawingml/2006/main" xmlns:r="http://schemas.openxmlformats.org/officeDocument/2006/relationships" xmlns:p="http://schemas.openxmlformats.org/presentationml/2006/main" preserve="1">
   <p:cSld name="DEFAULT">
@@ -4433,6 +4522,140 @@
                 <a:cs typeface="Calibri" pitchFamily="34" charset="-120"/>
               </a:rPr>
               <a:t>frozen map, boards</a:t>
+            </a:r>
+            <a:endParaRPr lang="en-US" sz="1100" dirty="0"/>
+          </a:p>
+        </p:txBody>
+      </p:sp>
+    </p:spTree>
+  </p:cSld>
+  <p:clrMapOvr>
+    <a:masterClrMapping/>
+  </p:clrMapOvr>
+</p:sld>
+</file>
+
+<file path=ppt/slides/slide3.xml><?xml version="1.0" encoding="utf-8"?>
+<p:sld xmlns:a="http://schemas.openxmlformats.org/drawingml/2006/main" xmlns:r="http://schemas.openxmlformats.org/officeDocument/2006/relationships" xmlns:p="http://schemas.openxmlformats.org/presentationml/2006/main">
+  <p:cSld name="Slide 3">
+    <p:bg>
+      <p:bgPr>
+        <a:solidFill>
+          <a:srgbClr val="FFFFFF"/>
+        </a:solidFill>
+      </p:bgPr>
+    </p:bg>
+    <p:spTree>
+      <p:nvGrpSpPr>
+        <p:cNvPr id="1" name=""/>
+        <p:cNvGrpSpPr/>
+        <p:nvPr/>
+      </p:nvGrpSpPr>
+      <p:grpSpPr>
+        <a:xfrm>
+          <a:off x="0" y="0"/>
+          <a:ext cx="0" cy="0"/>
+          <a:chOff x="0" y="0"/>
+          <a:chExt cx="0" cy="0"/>
+        </a:xfrm>
+      </p:grpSpPr>
+      <p:sp>
+        <p:nvSpPr>
+          <p:cNvPr id="2" name="Title"/>
+          <p:cNvSpPr txBox="1"/>
+          <p:nvPr/>
+        </p:nvSpPr>
+        <p:spPr>
+          <a:xfrm>
+            <a:off x="457200" y="365760"/>
+            <a:ext cx="11247120" cy="640080"/>
+          </a:xfrm>
+          <a:prstGeom prst="rect">
+            <a:avLst/>
+          </a:prstGeom>
+          <a:noFill/>
+          <a:ln/>
+        </p:spPr>
+        <p:txBody>
+          <a:bodyPr wrap="square" lIns="0" tIns="0" rIns="0" bIns="0" rtlCol="0" anchor="ctr"/>
+          <a:lstStyle/>
+          <a:p>
+            <a:pPr indent="0" marL="0">
+              <a:buNone/>
+            </a:pPr>
+            <a:r>
+              <a:rPr lang="en-US" sz="3200" b="1" dirty="0">
+                <a:solidFill>
+                  <a:srgbClr val="14213D"/>
+                </a:solidFill>
+                <a:latin typeface="Cambria" pitchFamily="34" charset="0"/>
+                <a:ea typeface="Cambria" pitchFamily="34" charset="-122"/>
+                <a:cs typeface="Cambria" pitchFamily="34" charset="-120"/>
+              </a:rPr>
+              <a:t>What each mapping step does to a wall</a:t>
+            </a:r>
+            <a:endParaRPr lang="en-US" sz="3200" dirty="0"/>
+          </a:p>
+        </p:txBody>
+      </p:sp>
+      <p:pic>
+        <p:nvPicPr>
+          <p:cNvPr id="3" name="Method figure" descr="Wall offsets before and after pose-time correction, plane bundle adjustment and TSDF fusion">    </p:cNvPr>
+          <p:cNvPicPr>
+            <a:picLocks noChangeAspect="1"/>
+          </p:cNvPicPr>
+          <p:nvPr/>
+        </p:nvPicPr>
+        <p:blipFill>
+          <a:blip r:embed="rId1"/>
+          <a:stretch>
+            <a:fillRect/>
+          </a:stretch>
+        </p:blipFill>
+        <p:spPr>
+          <a:xfrm>
+            <a:off x="1066648" y="1143000"/>
+            <a:ext cx="10058400" cy="5197777"/>
+          </a:xfrm>
+          <a:prstGeom prst="rect">
+            <a:avLst/>
+          </a:prstGeom>
+        </p:spPr>
+      </p:pic>
+      <p:sp>
+        <p:nvSpPr>
+          <p:cNvPr id="4" name="Source"/>
+          <p:cNvSpPr txBox="1"/>
+          <p:nvPr/>
+        </p:nvSpPr>
+        <p:spPr>
+          <a:xfrm>
+            <a:off x="457200" y="6400800"/>
+            <a:ext cx="11247120" cy="274320"/>
+          </a:xfrm>
+          <a:prstGeom prst="rect">
+            <a:avLst/>
+          </a:prstGeom>
+          <a:noFill/>
+          <a:ln/>
+        </p:spPr>
+        <p:txBody>
+          <a:bodyPr wrap="square" lIns="0" tIns="0" rIns="0" bIns="0" rtlCol="0" anchor="ctr"/>
+          <a:lstStyle/>
+          <a:p>
+            <a:pPr indent="0" marL="0">
+              <a:buNone/>
+            </a:pPr>
+            <a:r>
+              <a:rPr lang="en-US" sz="1100" i="1" dirty="0">
+                <a:solidFill>
+                  <a:srgbClr val="5A6475"/>
+                </a:solidFill>
+                <a:latin typeface="Calibri" pitchFamily="34" charset="0"/>
+                <a:ea typeface="Calibri" pitchFamily="34" charset="-122"/>
+                <a:cs typeface="Calibri" pitchFamily="34" charset="-120"/>
+              </a:rPr>
+              <a:t>Simulated room (top view); the dataset's numbers are in the tables</a:t>
             </a:r>
             <a:endParaRPr lang="en-US" sz="1100" dirty="0"/>
           </a:p>

</xml_diff>

<commit_message>
Method figure as schematic drawings: pose-time correction, plane BA, TSDF, wall thickness
Replaces the simulated wall plots with line drawings of how each step
works (the TSDF panel's field and surface are computed); one PNG per step
for slides 3-6 of the pipeline PPT, each with its 20261015 result.

Co-Authored-By: Claude Opus 5.5 <noreply@anthropic.com>
Claude-Session: https://claude.ai/code/session_01VemgbrpoRNyLKBeEk6r3sF
</commit_message>
<xml_diff>
--- a/scoop_testbed_paper/figs/fig_refpipeline.pptx
+++ b/scoop_testbed_paper/figs/fig_refpipeline.pptx
@@ -8,9 +8,12 @@
     <p:sldId id="256" r:id="rId2"/>
     <p:sldId id="257" r:id="rId3"/>
     <p:sldId id="258" r:id="rId4"/>
+    <p:sldId id="259" r:id="rId5"/>
+    <p:sldId id="260" r:id="rId6"/>
+    <p:sldId id="261" r:id="rId7"/>
   </p:sldIdLst>
   <p:notesMasterIdLst>
-    <p:notesMasterId r:id="rId5"/>
+    <p:notesMasterId r:id="rId8"/>
   </p:notesMasterIdLst>
   <p:sldSz cx="12192000" cy="6858000"/>
   <p:notesSz cx="6858000" cy="12192000"/>
@@ -680,7 +683,7 @@
           <a:p>
             <a:r>
               <a:rPr lang="en-US" dirty="0"/>
-              <a:t>One wall, seen from above, before and after each step; the shaded bars are the 5-95 % spread of each 0.25 m patch, the wall thickness. (a) GLIM writes each pose with the start of its sweep, 50 ms before the scan's middle; while turning, the scans land off the wall. Moving the poses 46 ms on export leaves 4 ms and the wall is as thin as the sensor. (b) Small odometry drift places the same wall differently on each visit; plane bundle adjustment moves all keyframes together until every plane is as thin as the scans allow. (c) The union keeps every cell any scan hit, so the band grows with every pass; the TSDF averages the rays' signed distances and keeps one surface at their mean. This is a simulation with perfectly flat walls; on the real 20261015 map the TSDF walls are 7.8 cm against 12.8 cm for the union.</a:t>
+              <a:t>GLIM writes each pose with the time its sweep started, but the pose describes the robot about half a sweep later. Looking up the pose at a scan's own time therefore gives where the robot was 50 ms later; while turning, that scan lands beside the walls. We move every pose 46 ms on export, and check the remaining offset on every pass.</a:t>
             </a:r>
             <a:endParaRPr lang="en-US" dirty="0"/>
           </a:p>
@@ -704,6 +707,270 @@
             <a:fld id="{F7021451-1387-4CA6-816F-3879F97B5CBC}" type="slidenum">
               <a:rPr lang="en-US"/>
               <a:t>3</a:t>
+            </a:fld>
+            <a:endParaRPr lang="en-US"/>
+          </a:p>
+        </p:txBody>
+      </p:sp>
+    </p:spTree>
+    <p:extLst>
+      <p:ext uri="{BB962C8B-B14F-4D97-AF65-F5344CB8AC3E}">
+        <p14:creationId xmlns:p14="http://schemas.microsoft.com/office/powerpoint/2010/main" val="1024086991"/>
+      </p:ext>
+    </p:extLst>
+  </p:cSld>
+  <p:clrMapOvr>
+    <a:masterClrMapping/>
+  </p:clrMapOvr>
+</p:notes>
+</file>
+
+<file path=ppt/notesSlides/notesSlide4.xml><?xml version="1.0" encoding="utf-8"?>
+<p:notes xmlns:a="http://schemas.openxmlformats.org/drawingml/2006/main" xmlns:r="http://schemas.openxmlformats.org/officeDocument/2006/relationships" xmlns:p="http://schemas.openxmlformats.org/presentationml/2006/main">
+  <p:cSld>
+    <p:spTree>
+      <p:nvGrpSpPr>
+        <p:cNvPr id="1" name=""/>
+        <p:cNvGrpSpPr/>
+        <p:nvPr/>
+      </p:nvGrpSpPr>
+      <p:grpSpPr>
+        <a:xfrm>
+          <a:off x="0" y="0"/>
+          <a:ext cx="0" cy="0"/>
+          <a:chOff x="0" y="0"/>
+          <a:chExt cx="0" cy="0"/>
+        </a:xfrm>
+      </p:grpSpPr>
+      <p:sp>
+        <p:nvSpPr>
+          <p:cNvPr id="2" name="Slide Image Placeholder 1"/>
+          <p:cNvSpPr>
+            <a:spLocks noGrp="1" noRot="1" noChangeAspect="1"/>
+          </p:cNvSpPr>
+          <p:nvPr>
+            <p:ph type="sldImg"/>
+          </p:nvPr>
+        </p:nvSpPr>
+        <p:spPr/>
+      </p:sp>
+      <p:sp>
+        <p:nvSpPr>
+          <p:cNvPr id="3" name="Notes Placeholder 2"/>
+          <p:cNvSpPr>
+            <a:spLocks noGrp="1"/>
+          </p:cNvSpPr>
+          <p:nvPr>
+            <p:ph type="body" idx="1"/>
+          </p:nvPr>
+        </p:nvSpPr>
+        <p:spPr/>
+        <p:txBody>
+          <a:bodyPr/>
+          <a:lstStyle/>
+          <a:p>
+            <a:r>
+              <a:rPr lang="en-US" dirty="0"/>
+              <a:t>Like bundle adjustment with cameras, but the shared features are planes instead of points. Each keyframe sees part of a plane; if its pose is off, its points sit above or below the others. The plane is fitted in closed form, and all poses are moved together until every plane is as thin as the scans allow.</a:t>
+            </a:r>
+            <a:endParaRPr lang="en-US" dirty="0"/>
+          </a:p>
+        </p:txBody>
+      </p:sp>
+      <p:sp>
+        <p:nvSpPr>
+          <p:cNvPr id="4" name="Slide Number Placeholder 3"/>
+          <p:cNvSpPr>
+            <a:spLocks noGrp="1"/>
+          </p:cNvSpPr>
+          <p:nvPr>
+            <p:ph type="sldNum" sz="quarter" idx="10"/>
+          </p:nvPr>
+        </p:nvSpPr>
+        <p:spPr/>
+        <p:txBody>
+          <a:bodyPr/>
+          <a:lstStyle/>
+          <a:p>
+            <a:fld id="{F7021451-1387-4CA6-816F-3879F97B5CBC}" type="slidenum">
+              <a:rPr lang="en-US"/>
+              <a:t>4</a:t>
+            </a:fld>
+            <a:endParaRPr lang="en-US"/>
+          </a:p>
+        </p:txBody>
+      </p:sp>
+    </p:spTree>
+    <p:extLst>
+      <p:ext uri="{BB962C8B-B14F-4D97-AF65-F5344CB8AC3E}">
+        <p14:creationId xmlns:p14="http://schemas.microsoft.com/office/powerpoint/2010/main" val="1024086991"/>
+      </p:ext>
+    </p:extLst>
+  </p:cSld>
+  <p:clrMapOvr>
+    <a:masterClrMapping/>
+  </p:clrMapOvr>
+</p:notes>
+</file>
+
+<file path=ppt/notesSlides/notesSlide5.xml><?xml version="1.0" encoding="utf-8"?>
+<p:notes xmlns:a="http://schemas.openxmlformats.org/drawingml/2006/main" xmlns:r="http://schemas.openxmlformats.org/officeDocument/2006/relationships" xmlns:p="http://schemas.openxmlformats.org/presentationml/2006/main">
+  <p:cSld>
+    <p:spTree>
+      <p:nvGrpSpPr>
+        <p:cNvPr id="1" name=""/>
+        <p:cNvGrpSpPr/>
+        <p:nvPr/>
+      </p:nvGrpSpPr>
+      <p:grpSpPr>
+        <a:xfrm>
+          <a:off x="0" y="0"/>
+          <a:ext cx="0" cy="0"/>
+          <a:chOff x="0" y="0"/>
+          <a:chExt cx="0" cy="0"/>
+        </a:xfrm>
+      </p:grpSpPr>
+      <p:sp>
+        <p:nvSpPr>
+          <p:cNvPr id="2" name="Slide Image Placeholder 1"/>
+          <p:cNvSpPr>
+            <a:spLocks noGrp="1" noRot="1" noChangeAspect="1"/>
+          </p:cNvSpPr>
+          <p:nvPr>
+            <p:ph type="sldImg"/>
+          </p:nvPr>
+        </p:nvSpPr>
+        <p:spPr/>
+      </p:sp>
+      <p:sp>
+        <p:nvSpPr>
+          <p:cNvPr id="3" name="Notes Placeholder 2"/>
+          <p:cNvSpPr>
+            <a:spLocks noGrp="1"/>
+          </p:cNvSpPr>
+          <p:nvPr>
+            <p:ph type="body" idx="1"/>
+          </p:nvPr>
+        </p:nvSpPr>
+        <p:spPr/>
+        <p:txBody>
+          <a:bodyPr/>
+          <a:lstStyle/>
+          <a:p>
+            <a:r>
+              <a:rPr lang="en-US" dirty="0"/>
+              <a:t>The union of points keeps every cell any scan ever hit, so a rarely hit cell counts as much as the dense centre and walls grow thicker with every pass. The TSDF instead averages, along each ray, how far each cell is in front of or behind the hit, and puts the surface where that average is zero.</a:t>
+            </a:r>
+            <a:endParaRPr lang="en-US" dirty="0"/>
+          </a:p>
+        </p:txBody>
+      </p:sp>
+      <p:sp>
+        <p:nvSpPr>
+          <p:cNvPr id="4" name="Slide Number Placeholder 3"/>
+          <p:cNvSpPr>
+            <a:spLocks noGrp="1"/>
+          </p:cNvSpPr>
+          <p:nvPr>
+            <p:ph type="sldNum" sz="quarter" idx="10"/>
+          </p:nvPr>
+        </p:nvSpPr>
+        <p:spPr/>
+        <p:txBody>
+          <a:bodyPr/>
+          <a:lstStyle/>
+          <a:p>
+            <a:fld id="{F7021451-1387-4CA6-816F-3879F97B5CBC}" type="slidenum">
+              <a:rPr lang="en-US"/>
+              <a:t>5</a:t>
+            </a:fld>
+            <a:endParaRPr lang="en-US"/>
+          </a:p>
+        </p:txBody>
+      </p:sp>
+    </p:spTree>
+    <p:extLst>
+      <p:ext uri="{BB962C8B-B14F-4D97-AF65-F5344CB8AC3E}">
+        <p14:creationId xmlns:p14="http://schemas.microsoft.com/office/powerpoint/2010/main" val="1024086991"/>
+      </p:ext>
+    </p:extLst>
+  </p:cSld>
+  <p:clrMapOvr>
+    <a:masterClrMapping/>
+  </p:clrMapOvr>
+</p:notes>
+</file>
+
+<file path=ppt/notesSlides/notesSlide6.xml><?xml version="1.0" encoding="utf-8"?>
+<p:notes xmlns:a="http://schemas.openxmlformats.org/drawingml/2006/main" xmlns:r="http://schemas.openxmlformats.org/officeDocument/2006/relationships" xmlns:p="http://schemas.openxmlformats.org/presentationml/2006/main">
+  <p:cSld>
+    <p:spTree>
+      <p:nvGrpSpPr>
+        <p:cNvPr id="1" name=""/>
+        <p:cNvGrpSpPr/>
+        <p:nvPr/>
+      </p:nvGrpSpPr>
+      <p:grpSpPr>
+        <a:xfrm>
+          <a:off x="0" y="0"/>
+          <a:ext cx="0" cy="0"/>
+          <a:chOff x="0" y="0"/>
+          <a:chExt cx="0" cy="0"/>
+        </a:xfrm>
+      </p:grpSpPr>
+      <p:sp>
+        <p:nvSpPr>
+          <p:cNvPr id="2" name="Slide Image Placeholder 1"/>
+          <p:cNvSpPr>
+            <a:spLocks noGrp="1" noRot="1" noChangeAspect="1"/>
+          </p:cNvSpPr>
+          <p:nvPr>
+            <p:ph type="sldImg"/>
+          </p:nvPr>
+        </p:nvSpPr>
+        <p:spPr/>
+      </p:sp>
+      <p:sp>
+        <p:nvSpPr>
+          <p:cNvPr id="3" name="Notes Placeholder 2"/>
+          <p:cNvSpPr>
+            <a:spLocks noGrp="1"/>
+          </p:cNvSpPr>
+          <p:nvPr>
+            <p:ph type="body" idx="1"/>
+          </p:nvPr>
+        </p:nvSpPr>
+        <p:spPr/>
+        <p:txBody>
+          <a:bodyPr/>
+          <a:lstStyle/>
+          <a:p>
+            <a:r>
+              <a:rPr lang="en-US" dirty="0"/>
+              <a:t>This is how every thickness in the tables is measured. The same patches are measured with the points of one scan, of one second, or of the whole run as placed by the trajectory; each scan against its own plane gives the sensor alone.</a:t>
+            </a:r>
+            <a:endParaRPr lang="en-US" dirty="0"/>
+          </a:p>
+        </p:txBody>
+      </p:sp>
+      <p:sp>
+        <p:nvSpPr>
+          <p:cNvPr id="4" name="Slide Number Placeholder 3"/>
+          <p:cNvSpPr>
+            <a:spLocks noGrp="1"/>
+          </p:cNvSpPr>
+          <p:nvPr>
+            <p:ph type="sldNum" sz="quarter" idx="10"/>
+          </p:nvPr>
+        </p:nvSpPr>
+        <p:spPr/>
+        <p:txBody>
+          <a:bodyPr/>
+          <a:lstStyle/>
+          <a:p>
+            <a:fld id="{F7021451-1387-4CA6-816F-3879F97B5CBC}" type="slidenum">
+              <a:rPr lang="en-US"/>
+              <a:t>6</a:t>
             </a:fld>
             <a:endParaRPr lang="en-US"/>
           </a:p>
@@ -4592,7 +4859,7 @@
                 <a:ea typeface="Cambria" pitchFamily="34" charset="-122"/>
                 <a:cs typeface="Cambria" pitchFamily="34" charset="-120"/>
               </a:rPr>
-              <a:t>What each mapping step does to a wall</a:t>
+              <a:t>Pose-time correction</a:t>
             </a:r>
             <a:endParaRPr lang="en-US" sz="3200" dirty="0"/>
           </a:p>
@@ -4600,7 +4867,7 @@
       </p:sp>
       <p:pic>
         <p:nvPicPr>
-          <p:cNvPr id="3" name="Method figure" descr="Wall offsets before and after pose-time correction, plane bundle adjustment and TSDF fusion">    </p:cNvPr>
+          <p:cNvPr id="3" name="Drawing" descr="Pose-time correction: schematic drawing">    </p:cNvPr>
           <p:cNvPicPr>
             <a:picLocks noChangeAspect="1"/>
           </p:cNvPicPr>
@@ -4614,8 +4881,8 @@
         </p:blipFill>
         <p:spPr>
           <a:xfrm>
-            <a:off x="1066648" y="1143000"/>
-            <a:ext cx="10058400" cy="5197777"/>
+            <a:off x="320040" y="1234440"/>
+            <a:ext cx="6360504" cy="5212080"/>
           </a:xfrm>
           <a:prstGeom prst="rect">
             <a:avLst/>
@@ -4624,14 +4891,14 @@
       </p:pic>
       <p:sp>
         <p:nvSpPr>
-          <p:cNvPr id="4" name="Source"/>
+          <p:cNvPr id="4" name="Bullets"/>
           <p:cNvSpPr txBox="1"/>
           <p:nvPr/>
         </p:nvSpPr>
         <p:spPr>
           <a:xfrm>
-            <a:off x="457200" y="6400800"/>
-            <a:ext cx="11247120" cy="274320"/>
+            <a:off x="7000584" y="1554480"/>
+            <a:ext cx="4733911" cy="3291840"/>
           </a:xfrm>
           <a:prstGeom prst="rect">
             <a:avLst/>
@@ -4640,6 +4907,170 @@
           <a:ln/>
         </p:spPr>
         <p:txBody>
+          <a:bodyPr wrap="square" lIns="0" tIns="0" rIns="0" bIns="0" rtlCol="0" anchor="t"/>
+          <a:lstStyle/>
+          <a:p>
+            <a:pPr marL="342900" indent="-342900">
+              <a:spcAft>
+                <a:spcPts val="1200"/>
+              </a:spcAft>
+              <a:buSzPct val="100000"/>
+              <a:buChar char="•"/>
+            </a:pPr>
+            <a:r>
+              <a:rPr lang="en-US" sz="1700" dirty="0">
+                <a:solidFill>
+                  <a:srgbClr val="14213D"/>
+                </a:solidFill>
+                <a:latin typeface="Calibri" pitchFamily="34" charset="0"/>
+                <a:ea typeface="Calibri" pitchFamily="34" charset="-122"/>
+                <a:cs typeface="Calibri" pitchFamily="34" charset="-120"/>
+              </a:rPr>
+              <a:t>GLIM stamps each pose with the start of its LiDAR sweep; the pose is the robot about half a sweep (50 ms) later.</a:t>
+            </a:r>
+            <a:endParaRPr lang="en-US" sz="1700" dirty="0"/>
+          </a:p>
+          <a:p>
+            <a:pPr marL="342900" indent="-342900">
+              <a:spcAft>
+                <a:spcPts val="1200"/>
+              </a:spcAft>
+              <a:buSzPct val="100000"/>
+              <a:buChar char="•"/>
+            </a:pPr>
+            <a:r>
+              <a:rPr lang="en-US" sz="1700" dirty="0">
+                <a:solidFill>
+                  <a:srgbClr val="14213D"/>
+                </a:solidFill>
+                <a:latin typeface="Calibri" pitchFamily="34" charset="0"/>
+                <a:ea typeface="Calibri" pitchFamily="34" charset="-122"/>
+                <a:cs typeface="Calibri" pitchFamily="34" charset="-120"/>
+              </a:rPr>
+              <a:t>A scan placed with the pose stamped at its own time lands off the walls whenever the robot turns.</a:t>
+            </a:r>
+            <a:endParaRPr lang="en-US" sz="1700" dirty="0"/>
+          </a:p>
+          <a:p>
+            <a:pPr marL="342900" indent="-342900">
+              <a:spcAft>
+                <a:spcPts val="1200"/>
+              </a:spcAft>
+              <a:buSzPct val="100000"/>
+              <a:buChar char="•"/>
+            </a:pPr>
+            <a:r>
+              <a:rPr lang="en-US" sz="1700" dirty="0">
+                <a:solidFill>
+                  <a:srgbClr val="14213D"/>
+                </a:solidFill>
+                <a:latin typeface="Calibri" pitchFamily="34" charset="0"/>
+                <a:ea typeface="Calibri" pitchFamily="34" charset="-122"/>
+                <a:cs typeface="Calibri" pitchFamily="34" charset="-120"/>
+              </a:rPr>
+              <a:t>Fix: every pose moved +46 ms on export (recording.yaml, pose_time_offset).</a:t>
+            </a:r>
+            <a:endParaRPr lang="en-US" sz="1700" dirty="0"/>
+          </a:p>
+        </p:txBody>
+      </p:sp>
+      <p:sp>
+        <p:nvSpPr>
+          <p:cNvPr id="5" name="Result"/>
+          <p:cNvSpPr/>
+          <p:nvPr/>
+        </p:nvSpPr>
+        <p:spPr>
+          <a:xfrm>
+            <a:off x="7000584" y="5120640"/>
+            <a:ext cx="4733911" cy="822960"/>
+          </a:xfrm>
+          <a:prstGeom prst="roundRect">
+            <a:avLst>
+              <a:gd name="adj" fmla="val 8889"/>
+            </a:avLst>
+          </a:prstGeom>
+          <a:solidFill>
+            <a:srgbClr val="FBE6D0"/>
+          </a:solidFill>
+          <a:ln w="12700">
+            <a:solidFill>
+              <a:srgbClr val="D9822B"/>
+            </a:solidFill>
+          </a:ln>
+        </p:spPr>
+        <p:txBody>
+          <a:bodyPr wrap="square" lIns="101600" tIns="101600" rIns="101600" bIns="101600" rtlCol="0" anchor="ctr"/>
+          <a:lstStyle/>
+          <a:p>
+            <a:pPr algn="l" indent="0" marL="0">
+              <a:buNone/>
+            </a:pPr>
+            <a:r>
+              <a:rPr lang="en-US" sz="1500" b="1" dirty="0">
+                <a:solidFill>
+                  <a:srgbClr val="14213D"/>
+                </a:solidFill>
+                <a:latin typeface="Calibri" pitchFamily="34" charset="0"/>
+                <a:ea typeface="Calibri" pitchFamily="34" charset="-122"/>
+                <a:cs typeface="Calibri" pitchFamily="34" charset="-120"/>
+              </a:rPr>
+              <a:t>20261015: 4 ms left; checked on every pass (heading against turning rate)</a:t>
+            </a:r>
+            <a:endParaRPr lang="en-US" sz="1500" dirty="0"/>
+          </a:p>
+        </p:txBody>
+      </p:sp>
+    </p:spTree>
+  </p:cSld>
+  <p:clrMapOvr>
+    <a:masterClrMapping/>
+  </p:clrMapOvr>
+</p:sld>
+</file>
+
+<file path=ppt/slides/slide4.xml><?xml version="1.0" encoding="utf-8"?>
+<p:sld xmlns:a="http://schemas.openxmlformats.org/drawingml/2006/main" xmlns:r="http://schemas.openxmlformats.org/officeDocument/2006/relationships" xmlns:p="http://schemas.openxmlformats.org/presentationml/2006/main">
+  <p:cSld name="Slide 4">
+    <p:bg>
+      <p:bgPr>
+        <a:solidFill>
+          <a:srgbClr val="FFFFFF"/>
+        </a:solidFill>
+      </p:bgPr>
+    </p:bg>
+    <p:spTree>
+      <p:nvGrpSpPr>
+        <p:cNvPr id="1" name=""/>
+        <p:cNvGrpSpPr/>
+        <p:nvPr/>
+      </p:nvGrpSpPr>
+      <p:grpSpPr>
+        <a:xfrm>
+          <a:off x="0" y="0"/>
+          <a:ext cx="0" cy="0"/>
+          <a:chOff x="0" y="0"/>
+          <a:chExt cx="0" cy="0"/>
+        </a:xfrm>
+      </p:grpSpPr>
+      <p:sp>
+        <p:nvSpPr>
+          <p:cNvPr id="2" name="Title"/>
+          <p:cNvSpPr txBox="1"/>
+          <p:nvPr/>
+        </p:nvSpPr>
+        <p:spPr>
+          <a:xfrm>
+            <a:off x="457200" y="365760"/>
+            <a:ext cx="11247120" cy="640080"/>
+          </a:xfrm>
+          <a:prstGeom prst="rect">
+            <a:avLst/>
+          </a:prstGeom>
+          <a:noFill/>
+          <a:ln/>
+        </p:spPr>
+        <p:txBody>
           <a:bodyPr wrap="square" lIns="0" tIns="0" rIns="0" bIns="0" rtlCol="0" anchor="ctr"/>
           <a:lstStyle/>
           <a:p>
@@ -4647,17 +5078,627 @@
               <a:buNone/>
             </a:pPr>
             <a:r>
-              <a:rPr lang="en-US" sz="1100" i="1" dirty="0">
-                <a:solidFill>
-                  <a:srgbClr val="5A6475"/>
-                </a:solidFill>
-                <a:latin typeface="Calibri" pitchFamily="34" charset="0"/>
-                <a:ea typeface="Calibri" pitchFamily="34" charset="-122"/>
-                <a:cs typeface="Calibri" pitchFamily="34" charset="-120"/>
-              </a:rPr>
-              <a:t>Simulated room (top view); the dataset's numbers are in the tables</a:t>
-            </a:r>
-            <a:endParaRPr lang="en-US" sz="1100" dirty="0"/>
+              <a:rPr lang="en-US" sz="3200" b="1" dirty="0">
+                <a:solidFill>
+                  <a:srgbClr val="14213D"/>
+                </a:solidFill>
+                <a:latin typeface="Cambria" pitchFamily="34" charset="0"/>
+                <a:ea typeface="Cambria" pitchFamily="34" charset="-122"/>
+                <a:cs typeface="Cambria" pitchFamily="34" charset="-120"/>
+              </a:rPr>
+              <a:t>Plane bundle adjustment</a:t>
+            </a:r>
+            <a:endParaRPr lang="en-US" sz="3200" dirty="0"/>
+          </a:p>
+        </p:txBody>
+      </p:sp>
+      <p:pic>
+        <p:nvPicPr>
+          <p:cNvPr id="3" name="Drawing" descr="Plane bundle adjustment: schematic drawing">    </p:cNvPr>
+          <p:cNvPicPr>
+            <a:picLocks noChangeAspect="1"/>
+          </p:cNvPicPr>
+          <p:nvPr/>
+        </p:nvPicPr>
+        <p:blipFill>
+          <a:blip r:embed="rId1"/>
+          <a:stretch>
+            <a:fillRect/>
+          </a:stretch>
+        </p:blipFill>
+        <p:spPr>
+          <a:xfrm>
+            <a:off x="320040" y="1234440"/>
+            <a:ext cx="6360504" cy="5212080"/>
+          </a:xfrm>
+          <a:prstGeom prst="rect">
+            <a:avLst/>
+          </a:prstGeom>
+        </p:spPr>
+      </p:pic>
+      <p:sp>
+        <p:nvSpPr>
+          <p:cNvPr id="4" name="Bullets"/>
+          <p:cNvSpPr txBox="1"/>
+          <p:nvPr/>
+        </p:nvSpPr>
+        <p:spPr>
+          <a:xfrm>
+            <a:off x="7000584" y="1554480"/>
+            <a:ext cx="4733911" cy="3291840"/>
+          </a:xfrm>
+          <a:prstGeom prst="rect">
+            <a:avLst/>
+          </a:prstGeom>
+          <a:noFill/>
+          <a:ln/>
+        </p:spPr>
+        <p:txBody>
+          <a:bodyPr wrap="square" lIns="0" tIns="0" rIns="0" bIns="0" rtlCol="0" anchor="t"/>
+          <a:lstStyle/>
+          <a:p>
+            <a:pPr marL="342900" indent="-342900">
+              <a:spcAft>
+                <a:spcPts val="1200"/>
+              </a:spcAft>
+              <a:buSzPct val="100000"/>
+              <a:buChar char="•"/>
+            </a:pPr>
+            <a:r>
+              <a:rPr lang="en-US" sz="1700" dirty="0">
+                <a:solidFill>
+                  <a:srgbClr val="14213D"/>
+                </a:solidFill>
+                <a:latin typeface="Calibri" pitchFamily="34" charset="0"/>
+                <a:ea typeface="Calibri" pitchFamily="34" charset="-122"/>
+                <a:cs typeface="Calibri" pitchFamily="34" charset="-120"/>
+              </a:rPr>
+              <a:t>Keyframes: 1 s of scans each. Planes: flat 0.5 m cubes seen by at least 3 keyframes.</a:t>
+            </a:r>
+            <a:endParaRPr lang="en-US" sz="1700" dirty="0"/>
+          </a:p>
+          <a:p>
+            <a:pPr marL="342900" indent="-342900">
+              <a:spcAft>
+                <a:spcPts val="1200"/>
+              </a:spcAft>
+              <a:buSzPct val="100000"/>
+              <a:buChar char="•"/>
+            </a:pPr>
+            <a:r>
+              <a:rPr lang="en-US" sz="1700" dirty="0">
+                <a:solidFill>
+                  <a:srgbClr val="14213D"/>
+                </a:solidFill>
+                <a:latin typeface="Calibri" pitchFamily="34" charset="0"/>
+                <a:ea typeface="Calibri" pitchFamily="34" charset="-122"/>
+                <a:cs typeface="Calibri" pitchFamily="34" charset="-120"/>
+              </a:rPr>
+              <a:t>Each plane is solved in closed form, so only the poses are unknown; the cost is every plane's thickness squared.</a:t>
+            </a:r>
+            <a:endParaRPr lang="en-US" sz="1700" dirty="0"/>
+          </a:p>
+          <a:p>
+            <a:pPr marL="342900" indent="-342900">
+              <a:spcAft>
+                <a:spcPts val="1200"/>
+              </a:spcAft>
+              <a:buSzPct val="100000"/>
+              <a:buChar char="•"/>
+            </a:pPr>
+            <a:r>
+              <a:rPr lang="en-US" sz="1700" dirty="0">
+                <a:solidFill>
+                  <a:srgbClr val="14213D"/>
+                </a:solidFill>
+                <a:latin typeface="Calibri" pitchFamily="34" charset="0"/>
+                <a:ea typeface="Calibri" pitchFamily="34" charset="-122"/>
+                <a:cs typeface="Calibri" pitchFamily="34" charset="-120"/>
+              </a:rPr>
+              <a:t>All keyframe poses move together; odometry keeps what no plane sees, gravity holds roll and pitch; 3 rounds.</a:t>
+            </a:r>
+            <a:endParaRPr lang="en-US" sz="1700" dirty="0"/>
+          </a:p>
+        </p:txBody>
+      </p:sp>
+      <p:sp>
+        <p:nvSpPr>
+          <p:cNvPr id="5" name="Result"/>
+          <p:cNvSpPr/>
+          <p:nvPr/>
+        </p:nvSpPr>
+        <p:spPr>
+          <a:xfrm>
+            <a:off x="7000584" y="5120640"/>
+            <a:ext cx="4733911" cy="822960"/>
+          </a:xfrm>
+          <a:prstGeom prst="roundRect">
+            <a:avLst>
+              <a:gd name="adj" fmla="val 8889"/>
+            </a:avLst>
+          </a:prstGeom>
+          <a:solidFill>
+            <a:srgbClr val="FBE6D0"/>
+          </a:solidFill>
+          <a:ln w="12700">
+            <a:solidFill>
+              <a:srgbClr val="D9822B"/>
+            </a:solidFill>
+          </a:ln>
+        </p:spPr>
+        <p:txBody>
+          <a:bodyPr wrap="square" lIns="101600" tIns="101600" rIns="101600" bIns="101600" rtlCol="0" anchor="ctr"/>
+          <a:lstStyle/>
+          <a:p>
+            <a:pPr algn="l" indent="0" marL="0">
+              <a:buNone/>
+            </a:pPr>
+            <a:r>
+              <a:rPr lang="en-US" sz="1500" b="1" dirty="0">
+                <a:solidFill>
+                  <a:srgbClr val="14213D"/>
+                </a:solidFill>
+                <a:latin typeface="Calibri" pitchFamily="34" charset="0"/>
+                <a:ea typeface="Calibri" pitchFamily="34" charset="-122"/>
+                <a:cs typeface="Calibri" pitchFamily="34" charset="-120"/>
+              </a:rPr>
+              <a:t>20261015: whole-run walls 12.3 cm (GLIM as output) → 9.0 cm (reference)</a:t>
+            </a:r>
+            <a:endParaRPr lang="en-US" sz="1500" dirty="0"/>
+          </a:p>
+        </p:txBody>
+      </p:sp>
+    </p:spTree>
+  </p:cSld>
+  <p:clrMapOvr>
+    <a:masterClrMapping/>
+  </p:clrMapOvr>
+</p:sld>
+</file>
+
+<file path=ppt/slides/slide5.xml><?xml version="1.0" encoding="utf-8"?>
+<p:sld xmlns:a="http://schemas.openxmlformats.org/drawingml/2006/main" xmlns:r="http://schemas.openxmlformats.org/officeDocument/2006/relationships" xmlns:p="http://schemas.openxmlformats.org/presentationml/2006/main">
+  <p:cSld name="Slide 5">
+    <p:bg>
+      <p:bgPr>
+        <a:solidFill>
+          <a:srgbClr val="FFFFFF"/>
+        </a:solidFill>
+      </p:bgPr>
+    </p:bg>
+    <p:spTree>
+      <p:nvGrpSpPr>
+        <p:cNvPr id="1" name=""/>
+        <p:cNvGrpSpPr/>
+        <p:nvPr/>
+      </p:nvGrpSpPr>
+      <p:grpSpPr>
+        <a:xfrm>
+          <a:off x="0" y="0"/>
+          <a:ext cx="0" cy="0"/>
+          <a:chOff x="0" y="0"/>
+          <a:chExt cx="0" cy="0"/>
+        </a:xfrm>
+      </p:grpSpPr>
+      <p:sp>
+        <p:nvSpPr>
+          <p:cNvPr id="2" name="Title"/>
+          <p:cNvSpPr txBox="1"/>
+          <p:nvPr/>
+        </p:nvSpPr>
+        <p:spPr>
+          <a:xfrm>
+            <a:off x="457200" y="365760"/>
+            <a:ext cx="11247120" cy="640080"/>
+          </a:xfrm>
+          <a:prstGeom prst="rect">
+            <a:avLst/>
+          </a:prstGeom>
+          <a:noFill/>
+          <a:ln/>
+        </p:spPr>
+        <p:txBody>
+          <a:bodyPr wrap="square" lIns="0" tIns="0" rIns="0" bIns="0" rtlCol="0" anchor="ctr"/>
+          <a:lstStyle/>
+          <a:p>
+            <a:pPr indent="0" marL="0">
+              <a:buNone/>
+            </a:pPr>
+            <a:r>
+              <a:rPr lang="en-US" sz="3200" b="1" dirty="0">
+                <a:solidFill>
+                  <a:srgbClr val="14213D"/>
+                </a:solidFill>
+                <a:latin typeface="Cambria" pitchFamily="34" charset="0"/>
+                <a:ea typeface="Cambria" pitchFamily="34" charset="-122"/>
+                <a:cs typeface="Cambria" pitchFamily="34" charset="-120"/>
+              </a:rPr>
+              <a:t>TSDF fusion</a:t>
+            </a:r>
+            <a:endParaRPr lang="en-US" sz="3200" dirty="0"/>
+          </a:p>
+        </p:txBody>
+      </p:sp>
+      <p:pic>
+        <p:nvPicPr>
+          <p:cNvPr id="3" name="Drawing" descr="TSDF fusion: schematic drawing">    </p:cNvPr>
+          <p:cNvPicPr>
+            <a:picLocks noChangeAspect="1"/>
+          </p:cNvPicPr>
+          <p:nvPr/>
+        </p:nvPicPr>
+        <p:blipFill>
+          <a:blip r:embed="rId1"/>
+          <a:stretch>
+            <a:fillRect/>
+          </a:stretch>
+        </p:blipFill>
+        <p:spPr>
+          <a:xfrm>
+            <a:off x="320040" y="1234440"/>
+            <a:ext cx="6360504" cy="5212080"/>
+          </a:xfrm>
+          <a:prstGeom prst="rect">
+            <a:avLst/>
+          </a:prstGeom>
+        </p:spPr>
+      </p:pic>
+      <p:sp>
+        <p:nvSpPr>
+          <p:cNvPr id="4" name="Bullets"/>
+          <p:cNvSpPr txBox="1"/>
+          <p:nvPr/>
+        </p:nvSpPr>
+        <p:spPr>
+          <a:xfrm>
+            <a:off x="7000584" y="1554480"/>
+            <a:ext cx="4733911" cy="3291840"/>
+          </a:xfrm>
+          <a:prstGeom prst="rect">
+            <a:avLst/>
+          </a:prstGeom>
+          <a:noFill/>
+          <a:ln/>
+        </p:spPr>
+        <p:txBody>
+          <a:bodyPr wrap="square" lIns="0" tIns="0" rIns="0" bIns="0" rtlCol="0" anchor="t"/>
+          <a:lstStyle/>
+          <a:p>
+            <a:pPr marL="342900" indent="-342900">
+              <a:spcAft>
+                <a:spcPts val="1200"/>
+              </a:spcAft>
+              <a:buSzPct val="100000"/>
+              <a:buChar char="•"/>
+            </a:pPr>
+            <a:r>
+              <a:rPr lang="en-US" sz="1700" dirty="0">
+                <a:solidFill>
+                  <a:srgbClr val="14213D"/>
+                </a:solidFill>
+                <a:latin typeface="Calibri" pitchFamily="34" charset="0"/>
+                <a:ea typeface="Calibri" pitchFamily="34" charset="-122"/>
+                <a:cs typeface="Calibri" pitchFamily="34" charset="-120"/>
+              </a:rPr>
+              <a:t>Each point is a ray: every 2 cm cell within ±8 cm of the hit gets its signed distance (+ in front, − behind).</a:t>
+            </a:r>
+            <a:endParaRPr lang="en-US" sz="1700" dirty="0"/>
+          </a:p>
+          <a:p>
+            <a:pPr marL="342900" indent="-342900">
+              <a:spcAft>
+                <a:spcPts val="1200"/>
+              </a:spcAft>
+              <a:buSzPct val="100000"/>
+              <a:buChar char="•"/>
+            </a:pPr>
+            <a:r>
+              <a:rPr lang="en-US" sz="1700" dirty="0">
+                <a:solidFill>
+                  <a:srgbClr val="14213D"/>
+                </a:solidFill>
+                <a:latin typeface="Calibri" pitchFamily="34" charset="0"/>
+                <a:ea typeface="Calibri" pitchFamily="34" charset="-122"/>
+                <a:cs typeface="Calibri" pitchFamily="34" charset="-120"/>
+              </a:rPr>
+              <a:t>Averaged over all rays; the surface is where the average crosses zero (cells seen by at least 3 rays).</a:t>
+            </a:r>
+            <a:endParaRPr lang="en-US" sz="1700" dirty="0"/>
+          </a:p>
+          <a:p>
+            <a:pPr marL="342900" indent="-342900">
+              <a:spcAft>
+                <a:spcPts val="1200"/>
+              </a:spcAft>
+              <a:buSzPct val="100000"/>
+              <a:buChar char="•"/>
+            </a:pPr>
+            <a:r>
+              <a:rPr lang="en-US" sz="1700" dirty="0">
+                <a:solidFill>
+                  <a:srgbClr val="14213D"/>
+                </a:solidFill>
+                <a:latin typeface="Calibri" pitchFamily="34" charset="0"/>
+                <a:ea typeface="Calibri" pitchFamily="34" charset="-122"/>
+                <a:cs typeface="Calibri" pitchFamily="34" charset="-120"/>
+              </a:rPr>
+              <a:t>One surface instead of every cell any scan hit: the union's band grows with every pass.</a:t>
+            </a:r>
+            <a:endParaRPr lang="en-US" sz="1700" dirty="0"/>
+          </a:p>
+        </p:txBody>
+      </p:sp>
+      <p:sp>
+        <p:nvSpPr>
+          <p:cNvPr id="5" name="Result"/>
+          <p:cNvSpPr/>
+          <p:nvPr/>
+        </p:nvSpPr>
+        <p:spPr>
+          <a:xfrm>
+            <a:off x="7000584" y="5120640"/>
+            <a:ext cx="4733911" cy="822960"/>
+          </a:xfrm>
+          <a:prstGeom prst="roundRect">
+            <a:avLst>
+              <a:gd name="adj" fmla="val 8889"/>
+            </a:avLst>
+          </a:prstGeom>
+          <a:solidFill>
+            <a:srgbClr val="FBE6D0"/>
+          </a:solidFill>
+          <a:ln w="12700">
+            <a:solidFill>
+              <a:srgbClr val="D9822B"/>
+            </a:solidFill>
+          </a:ln>
+        </p:spPr>
+        <p:txBody>
+          <a:bodyPr wrap="square" lIns="101600" tIns="101600" rIns="101600" bIns="101600" rtlCol="0" anchor="ctr"/>
+          <a:lstStyle/>
+          <a:p>
+            <a:pPr algn="l" indent="0" marL="0">
+              <a:buNone/>
+            </a:pPr>
+            <a:r>
+              <a:rPr lang="en-US" sz="1500" b="1" dirty="0">
+                <a:solidFill>
+                  <a:srgbClr val="14213D"/>
+                </a:solidFill>
+                <a:latin typeface="Calibri" pitchFamily="34" charset="0"/>
+                <a:ea typeface="Calibri" pitchFamily="34" charset="-122"/>
+                <a:cs typeface="Calibri" pitchFamily="34" charset="-120"/>
+              </a:rPr>
+              <a:t>20261015: map walls 7.8 cm, against 12.8 cm for the union</a:t>
+            </a:r>
+            <a:endParaRPr lang="en-US" sz="1500" dirty="0"/>
+          </a:p>
+        </p:txBody>
+      </p:sp>
+    </p:spTree>
+  </p:cSld>
+  <p:clrMapOvr>
+    <a:masterClrMapping/>
+  </p:clrMapOvr>
+</p:sld>
+</file>
+
+<file path=ppt/slides/slide6.xml><?xml version="1.0" encoding="utf-8"?>
+<p:sld xmlns:a="http://schemas.openxmlformats.org/drawingml/2006/main" xmlns:r="http://schemas.openxmlformats.org/officeDocument/2006/relationships" xmlns:p="http://schemas.openxmlformats.org/presentationml/2006/main">
+  <p:cSld name="Slide 6">
+    <p:bg>
+      <p:bgPr>
+        <a:solidFill>
+          <a:srgbClr val="FFFFFF"/>
+        </a:solidFill>
+      </p:bgPr>
+    </p:bg>
+    <p:spTree>
+      <p:nvGrpSpPr>
+        <p:cNvPr id="1" name=""/>
+        <p:cNvGrpSpPr/>
+        <p:nvPr/>
+      </p:nvGrpSpPr>
+      <p:grpSpPr>
+        <a:xfrm>
+          <a:off x="0" y="0"/>
+          <a:ext cx="0" cy="0"/>
+          <a:chOff x="0" y="0"/>
+          <a:chExt cx="0" cy="0"/>
+        </a:xfrm>
+      </p:grpSpPr>
+      <p:sp>
+        <p:nvSpPr>
+          <p:cNvPr id="2" name="Title"/>
+          <p:cNvSpPr txBox="1"/>
+          <p:nvPr/>
+        </p:nvSpPr>
+        <p:spPr>
+          <a:xfrm>
+            <a:off x="457200" y="365760"/>
+            <a:ext cx="11247120" cy="640080"/>
+          </a:xfrm>
+          <a:prstGeom prst="rect">
+            <a:avLst/>
+          </a:prstGeom>
+          <a:noFill/>
+          <a:ln/>
+        </p:spPr>
+        <p:txBody>
+          <a:bodyPr wrap="square" lIns="0" tIns="0" rIns="0" bIns="0" rtlCol="0" anchor="ctr"/>
+          <a:lstStyle/>
+          <a:p>
+            <a:pPr indent="0" marL="0">
+              <a:buNone/>
+            </a:pPr>
+            <a:r>
+              <a:rPr lang="en-US" sz="3200" b="1" dirty="0">
+                <a:solidFill>
+                  <a:srgbClr val="14213D"/>
+                </a:solidFill>
+                <a:latin typeface="Cambria" pitchFamily="34" charset="0"/>
+                <a:ea typeface="Cambria" pitchFamily="34" charset="-122"/>
+                <a:cs typeface="Cambria" pitchFamily="34" charset="-120"/>
+              </a:rPr>
+              <a:t>Wall thickness</a:t>
+            </a:r>
+            <a:endParaRPr lang="en-US" sz="3200" dirty="0"/>
+          </a:p>
+        </p:txBody>
+      </p:sp>
+      <p:pic>
+        <p:nvPicPr>
+          <p:cNvPr id="3" name="Drawing" descr="Wall thickness: schematic drawing">    </p:cNvPr>
+          <p:cNvPicPr>
+            <a:picLocks noChangeAspect="1"/>
+          </p:cNvPicPr>
+          <p:nvPr/>
+        </p:nvPicPr>
+        <p:blipFill>
+          <a:blip r:embed="rId1"/>
+          <a:stretch>
+            <a:fillRect/>
+          </a:stretch>
+        </p:blipFill>
+        <p:spPr>
+          <a:xfrm>
+            <a:off x="320040" y="1234440"/>
+            <a:ext cx="6360504" cy="5212080"/>
+          </a:xfrm>
+          <a:prstGeom prst="rect">
+            <a:avLst/>
+          </a:prstGeom>
+        </p:spPr>
+      </p:pic>
+      <p:sp>
+        <p:nvSpPr>
+          <p:cNvPr id="4" name="Bullets"/>
+          <p:cNvSpPr txBox="1"/>
+          <p:nvPr/>
+        </p:nvSpPr>
+        <p:spPr>
+          <a:xfrm>
+            <a:off x="7000584" y="1554480"/>
+            <a:ext cx="4733911" cy="3291840"/>
+          </a:xfrm>
+          <a:prstGeom prst="rect">
+            <a:avLst/>
+          </a:prstGeom>
+          <a:noFill/>
+          <a:ln/>
+        </p:spPr>
+        <p:txBody>
+          <a:bodyPr wrap="square" lIns="0" tIns="0" rIns="0" bIns="0" rtlCol="0" anchor="t"/>
+          <a:lstStyle/>
+          <a:p>
+            <a:pPr marL="342900" indent="-342900">
+              <a:spcAft>
+                <a:spcPts val="1200"/>
+              </a:spcAft>
+              <a:buSzPct val="100000"/>
+              <a:buChar char="•"/>
+            </a:pPr>
+            <a:r>
+              <a:rPr lang="en-US" sz="1700" dirty="0">
+                <a:solidFill>
+                  <a:srgbClr val="14213D"/>
+                </a:solidFill>
+                <a:latin typeface="Calibri" pitchFamily="34" charset="0"/>
+                <a:ea typeface="Calibri" pitchFamily="34" charset="-122"/>
+                <a:cs typeface="Calibri" pitchFamily="34" charset="-120"/>
+              </a:rPr>
+              <a:t>Each 0.25 m patch: fit a plane, take the points' offsets along its normal.</a:t>
+            </a:r>
+            <a:endParaRPr lang="en-US" sz="1700" dirty="0"/>
+          </a:p>
+          <a:p>
+            <a:pPr marL="342900" indent="-342900">
+              <a:spcAft>
+                <a:spcPts val="1200"/>
+              </a:spcAft>
+              <a:buSzPct val="100000"/>
+              <a:buChar char="•"/>
+            </a:pPr>
+            <a:r>
+              <a:rPr lang="en-US" sz="1700" dirty="0">
+                <a:solidFill>
+                  <a:srgbClr val="14213D"/>
+                </a:solidFill>
+                <a:latin typeface="Calibri" pitchFamily="34" charset="0"/>
+                <a:ea typeface="Calibri" pitchFamily="34" charset="-122"/>
+                <a:cs typeface="Calibri" pitchFamily="34" charset="-120"/>
+              </a:rPr>
+              <a:t>Thickness = p95 − p5 of the offsets (3.29σ for Gaussian noise).</a:t>
+            </a:r>
+            <a:endParaRPr lang="en-US" sz="1700" dirty="0"/>
+          </a:p>
+          <a:p>
+            <a:pPr marL="342900" indent="-342900">
+              <a:spcAft>
+                <a:spcPts val="1200"/>
+              </a:spcAft>
+              <a:buSzPct val="100000"/>
+              <a:buChar char="•"/>
+            </a:pPr>
+            <a:r>
+              <a:rPr lang="en-US" sz="1700" dirty="0">
+                <a:solidFill>
+                  <a:srgbClr val="14213D"/>
+                </a:solidFill>
+                <a:latin typeface="Calibri" pitchFamily="34" charset="0"/>
+                <a:ea typeface="Calibri" pitchFamily="34" charset="-122"/>
+                <a:cs typeface="Calibri" pitchFamily="34" charset="-120"/>
+              </a:rPr>
+              <a:t>Points from one scan, 1 s or the whole run, as placed: separates sensor, motion and pose error.</a:t>
+            </a:r>
+            <a:endParaRPr lang="en-US" sz="1700" dirty="0"/>
+          </a:p>
+        </p:txBody>
+      </p:sp>
+      <p:sp>
+        <p:nvSpPr>
+          <p:cNvPr id="5" name="Result"/>
+          <p:cNvSpPr/>
+          <p:nvPr/>
+        </p:nvSpPr>
+        <p:spPr>
+          <a:xfrm>
+            <a:off x="7000584" y="5120640"/>
+            <a:ext cx="4733911" cy="822960"/>
+          </a:xfrm>
+          <a:prstGeom prst="roundRect">
+            <a:avLst>
+              <a:gd name="adj" fmla="val 8889"/>
+            </a:avLst>
+          </a:prstGeom>
+          <a:solidFill>
+            <a:srgbClr val="FBE6D0"/>
+          </a:solidFill>
+          <a:ln w="12700">
+            <a:solidFill>
+              <a:srgbClr val="D9822B"/>
+            </a:solidFill>
+          </a:ln>
+        </p:spPr>
+        <p:txBody>
+          <a:bodyPr wrap="square" lIns="101600" tIns="101600" rIns="101600" bIns="101600" rtlCol="0" anchor="ctr"/>
+          <a:lstStyle/>
+          <a:p>
+            <a:pPr algn="l" indent="0" marL="0">
+              <a:buNone/>
+            </a:pPr>
+            <a:r>
+              <a:rPr lang="en-US" sz="1500" b="1" dirty="0">
+                <a:solidFill>
+                  <a:srgbClr val="14213D"/>
+                </a:solidFill>
+                <a:latin typeface="Calibri" pitchFamily="34" charset="0"/>
+                <a:ea typeface="Calibri" pitchFamily="34" charset="-122"/>
+                <a:cs typeface="Calibri" pitchFamily="34" charset="-120"/>
+              </a:rPr>
+              <a:t>20261015 reference: sensor alone 3.0 · 1 scan 4.7 · 1 s 6.7 · whole run 9.0 cm</a:t>
+            </a:r>
+            <a:endParaRPr lang="en-US" sz="1500" dirty="0"/>
           </a:p>
         </p:txBody>
       </p:sp>

</xml_diff>